<commit_message>
Restore original ExamGrade navy/teal/gold colors and Cambria titles
Co-Authored-By: Claude Opus 5.5 <noreply@anthropic.com>
Claude-Session: https://claude.ai/code/session_01P1HuamEEch6HVKSN1LuXgZ
</commit_message>
<xml_diff>
--- a/presentations/ExamGrade_AI_Defence_v2.pptx
+++ b/presentations/ExamGrade_AI_Defence_v2.pptx
@@ -121,30 +121,30 @@
   <p:extLst>
     <p:ext uri="{521415D9-36F7-43E2-AB2F-B90AF26B5E84}">
       <p14:sectionLst xmlns:p14="http://schemas.microsoft.com/office/powerpoint/2010/main">
-        <p14:section name="Opening" id="{4adc2d69-e33c-df85-ed1a-703dd09aefc5}">
+        <p14:section name="Opening" id="{1a95b667-2af5-9123-c254-9ed6de6f1438}">
           <p14:sldIdLst>
             <p14:sldId id="256"/>
             <p14:sldId id="257"/>
           </p14:sldIdLst>
         </p14:section>
-        <p14:section name="Introduction" id="{591fbff0-fe04-bae4-54c3-78927b306a8c}">
+        <p14:section name="Introduction" id="{95c53ae0-5190-24b0-9d82-203b6c7cf3a2}">
           <p14:sldIdLst>
             <p14:sldId id="258"/>
             <p14:sldId id="259"/>
           </p14:sldIdLst>
         </p14:section>
-        <p14:section name="Diagnostic" id="{567897f3-53fe-5e9b-40d6-584a69fa0204}">
+        <p14:section name="Diagnostic" id="{6dc055b7-1f61-cca1-c899-abaa24d01806}">
           <p14:sldIdLst>
             <p14:sldId id="260"/>
           </p14:sldIdLst>
         </p14:section>
-        <p14:section name="Solution &amp; method" id="{e2f4da81-7cfd-a26c-6a0f-cbb3d78da897}">
+        <p14:section name="Solution &amp; method" id="{679d1996-b861-fb33-930c-9e2f93f3a59c}">
           <p14:sldIdLst>
             <p14:sldId id="261"/>
             <p14:sldId id="262"/>
           </p14:sldIdLst>
         </p14:section>
-        <p14:section name="Analysis &amp; design" id="{6f5d8511-f117-c7dc-c573-08bc2997a96b}">
+        <p14:section name="Analysis &amp; design" id="{4b34dcad-ac38-0905-6931-1ca82983d036}">
           <p14:sldIdLst>
             <p14:sldId id="263"/>
             <p14:sldId id="264"/>
@@ -152,13 +152,13 @@
             <p14:sldId id="266"/>
           </p14:sldIdLst>
         </p14:section>
-        <p14:section name="Implementation &amp; results" id="{18485517-f3b7-f252-e817-da637f883252}">
+        <p14:section name="Implementation &amp; results" id="{78b86738-563e-0a1d-db1b-cd7d89ed1003}">
           <p14:sldIdLst>
             <p14:sldId id="267"/>
             <p14:sldId id="268"/>
           </p14:sldIdLst>
         </p14:section>
-        <p14:section name="Conclusion" id="{664ddf2f-da78-72ea-4808-196c36b214d4}">
+        <p14:section name="Conclusion" id="{ce2a8ab7-820e-c7b7-5549-c7f101c2633b}">
           <p14:sldIdLst>
             <p14:sldId id="269"/>
             <p14:sldId id="270"/>
@@ -187,7 +187,7 @@
             <a:pPr>
               <a:defRPr sz="1300" b="0" i="0" u="none" strike="noStrike">
                 <a:solidFill>
-                  <a:srgbClr val="8B0000"/>
+                  <a:srgbClr val="1F3864"/>
                 </a:solidFill>
                 <a:latin typeface="+mn-lt"/>
               </a:defRPr>
@@ -195,7 +195,7 @@
             <a:r>
               <a:rPr sz="1300" b="0" i="0" u="none" strike="noStrike">
                 <a:solidFill>
-                  <a:srgbClr val="8B0000"/>
+                  <a:srgbClr val="1F3864"/>
                 </a:solidFill>
                 <a:latin typeface="+mn-lt"/>
               </a:rPr>
@@ -230,7 +230,7 @@
           </c:tx>
           <c:spPr>
             <a:solidFill>
-              <a:srgbClr val="6B5B5B"/>
+              <a:srgbClr val="64748B"/>
             </a:solidFill>
             <a:effectLst/>
           </c:spPr>
@@ -244,7 +244,7 @@
                 <a:pPr>
                   <a:defRPr b="0" i="0" strike="noStrike" sz="1200" u="none">
                     <a:solidFill>
-                      <a:srgbClr val="2C2C2C"/>
+                      <a:srgbClr val="1F2937"/>
                     </a:solidFill>
                     <a:latin typeface="+mn-lt"/>
                   </a:defRPr>
@@ -265,7 +265,7 @@
             <c:bubble3D val="0"/>
             <c:spPr>
               <a:solidFill>
-                <a:srgbClr val="6B5B5B"/>
+                <a:srgbClr val="64748B"/>
               </a:solidFill>
               <a:effectLst/>
             </c:spPr>
@@ -276,7 +276,7 @@
             <c:bubble3D val="0"/>
             <c:spPr>
               <a:solidFill>
-                <a:srgbClr val="B22222"/>
+                <a:srgbClr val="0F766E"/>
               </a:solidFill>
               <a:effectLst/>
             </c:spPr>
@@ -322,7 +322,7 @@
               <a:pPr>
                 <a:defRPr b="0" i="0" strike="noStrike" sz="1200" u="none">
                   <a:solidFill>
-                    <a:srgbClr val="2C2C2C"/>
+                    <a:srgbClr val="1F2937"/>
                   </a:solidFill>
                   <a:latin typeface="+mn-lt"/>
                 </a:defRPr>
@@ -370,7 +370,7 @@
             <a:pPr>
               <a:defRPr sz="1100" b="0" i="0" u="none" strike="noStrike">
                 <a:solidFill>
-                  <a:srgbClr val="2C2C2C"/>
+                  <a:srgbClr val="1F2937"/>
                 </a:solidFill>
                 <a:latin typeface="+mn-lt"/>
               </a:defRPr>
@@ -2152,7 +2152,7 @@
     <p:bg>
       <p:bgPr>
         <a:solidFill>
-          <a:schemeClr val="bg2"/>
+          <a:schemeClr val="bg1"/>
         </a:solidFill>
       </p:bgPr>
     </p:bg>
@@ -2185,7 +2185,7 @@
             <a:avLst/>
           </a:prstGeom>
           <a:solidFill>
-            <a:schemeClr val="accent1"/>
+            <a:schemeClr val="tx2"/>
           </a:solidFill>
           <a:ln/>
         </p:spPr>
@@ -2218,6 +2218,9 @@
                 <a:solidFill>
                   <a:schemeClr val="bg1"/>
                 </a:solidFill>
+                <a:latin typeface="Cambria" pitchFamily="34" charset="0"/>
+                <a:ea typeface="Cambria" pitchFamily="34" charset="-122"/>
+                <a:cs typeface="Cambria" pitchFamily="34" charset="-120"/>
               </a:defRPr>
             </a:lvl1pPr>
           </a:lstStyle>
@@ -2295,7 +2298,7 @@
             <a:lvl1pPr>
               <a:defRPr sz="1000">
                 <a:solidFill>
-                  <a:schemeClr val="accent2"/>
+                  <a:schemeClr val="tx2"/>
                 </a:solidFill>
               </a:defRPr>
             </a:lvl1pPr>
@@ -2324,7 +2327,7 @@
     <p:bg>
       <p:bgPr>
         <a:solidFill>
-          <a:schemeClr val="accent2"/>
+          <a:schemeClr val="tx2"/>
         </a:solidFill>
       </p:bgPr>
     </p:bg>
@@ -2397,7 +2400,7 @@
             <a:lvl1pPr>
               <a:defRPr sz="1000">
                 <a:solidFill>
-                  <a:schemeClr val="accent2"/>
+                  <a:schemeClr val="tx2"/>
                 </a:solidFill>
               </a:defRPr>
             </a:lvl1pPr>
@@ -2706,7 +2709,7 @@
             <a:avLst/>
           </a:prstGeom>
           <a:solidFill>
-            <a:schemeClr val="accent1"/>
+            <a:srgbClr val="2A4A80"/>
           </a:solidFill>
           <a:ln/>
         </p:spPr>
@@ -2732,14 +2735,14 @@
           </a:solidFill>
           <a:ln w="9525">
             <a:solidFill>
-              <a:schemeClr val="accent4"/>
+              <a:srgbClr val="D5DCE8"/>
             </a:solidFill>
             <a:prstDash val="solid"/>
           </a:ln>
           <a:effectLst>
             <a:outerShdw sx="100000" sy="100000" kx="0" ky="0" algn="bl" rotWithShape="0" blurRad="76200" dist="25400" dir="5400000">
-              <a:srgbClr val="8B0000">
-                <a:alpha val="12000"/>
+              <a:srgbClr val="1F3864">
+                <a:alpha val="10000"/>
               </a:srgbClr>
             </a:outerShdw>
           </a:effectLst>
@@ -2870,9 +2873,9 @@
                 <a:solidFill>
                   <a:schemeClr val="bg1"/>
                 </a:solidFill>
-                <a:latin typeface="Times New Roman" pitchFamily="34" charset="0"/>
-                <a:ea typeface="Times New Roman" pitchFamily="34" charset="-122"/>
-                <a:cs typeface="Times New Roman" pitchFamily="34" charset="-120"/>
+                <a:latin typeface="Cambria" pitchFamily="34" charset="0"/>
+                <a:ea typeface="Cambria" pitchFamily="34" charset="-122"/>
+                <a:cs typeface="Cambria" pitchFamily="34" charset="-120"/>
               </a:rPr>
               <a:t>Design and Implementation of an AI-Assisted Examination and Grading Platform with Human-in-the-Loop Validation: Case of G&amp;C Creative Technology</a:t>
             </a:r>
@@ -2895,7 +2898,7 @@
             <a:avLst/>
           </a:prstGeom>
           <a:solidFill>
-            <a:schemeClr val="accent3"/>
+            <a:srgbClr val="172B4D"/>
           </a:solidFill>
           <a:ln/>
         </p:spPr>
@@ -2927,7 +2930,7 @@
             <a:r>
               <a:rPr lang="en-US" sz="1300" b="1" spc="400" kern="0" dirty="0">
                 <a:solidFill>
-                  <a:schemeClr val="bg1"/>
+                  <a:schemeClr val="accent1"/>
                 </a:solidFill>
               </a:rPr>
               <a:t>INTERNSHIP DEFENCE PRESENTATION</a:t>
@@ -2968,9 +2971,9 @@
                 <a:solidFill>
                   <a:schemeClr val="bg1"/>
                 </a:solidFill>
-                <a:latin typeface="Times New Roman" pitchFamily="34" charset="0"/>
-                <a:ea typeface="Times New Roman" pitchFamily="34" charset="-122"/>
-                <a:cs typeface="Times New Roman" pitchFamily="34" charset="-120"/>
+                <a:latin typeface="Cambria" pitchFamily="34" charset="0"/>
+                <a:ea typeface="Cambria" pitchFamily="34" charset="-122"/>
+                <a:cs typeface="Cambria" pitchFamily="34" charset="-120"/>
               </a:rPr>
               <a:t>Presented by: </a:t>
             </a:r>
@@ -2985,9 +2988,9 @@
                 <a:solidFill>
                   <a:schemeClr val="bg1"/>
                 </a:solidFill>
-                <a:latin typeface="Times New Roman" pitchFamily="34" charset="0"/>
-                <a:ea typeface="Times New Roman" pitchFamily="34" charset="-122"/>
-                <a:cs typeface="Times New Roman" pitchFamily="34" charset="-120"/>
+                <a:latin typeface="Cambria" pitchFamily="34" charset="0"/>
+                <a:ea typeface="Cambria" pitchFamily="34" charset="-122"/>
+                <a:cs typeface="Cambria" pitchFamily="34" charset="-120"/>
               </a:rPr>
               <a:t>KENFACK MASSOMB PENSER</a:t>
             </a:r>
@@ -3005,9 +3008,9 @@
                 <a:solidFill>
                   <a:schemeClr val="bg1"/>
                 </a:solidFill>
-                <a:latin typeface="Times New Roman" pitchFamily="34" charset="0"/>
-                <a:ea typeface="Times New Roman" pitchFamily="34" charset="-122"/>
-                <a:cs typeface="Times New Roman" pitchFamily="34" charset="-120"/>
+                <a:latin typeface="Cambria" pitchFamily="34" charset="0"/>
+                <a:ea typeface="Cambria" pitchFamily="34" charset="-122"/>
+                <a:cs typeface="Cambria" pitchFamily="34" charset="-120"/>
               </a:rPr>
               <a:t>Degree: </a:t>
             </a:r>
@@ -3022,9 +3025,9 @@
                 <a:solidFill>
                   <a:schemeClr val="bg1"/>
                 </a:solidFill>
-                <a:latin typeface="Times New Roman" pitchFamily="34" charset="0"/>
-                <a:ea typeface="Times New Roman" pitchFamily="34" charset="-122"/>
-                <a:cs typeface="Times New Roman" pitchFamily="34" charset="-120"/>
+                <a:latin typeface="Cambria" pitchFamily="34" charset="0"/>
+                <a:ea typeface="Cambria" pitchFamily="34" charset="-122"/>
+                <a:cs typeface="Cambria" pitchFamily="34" charset="-120"/>
               </a:rPr>
               <a:t>Bachelor of Engineering, Computer Science Engineering</a:t>
             </a:r>
@@ -3042,9 +3045,9 @@
                 <a:solidFill>
                   <a:schemeClr val="bg1"/>
                 </a:solidFill>
-                <a:latin typeface="Times New Roman" pitchFamily="34" charset="0"/>
-                <a:ea typeface="Times New Roman" pitchFamily="34" charset="-122"/>
-                <a:cs typeface="Times New Roman" pitchFamily="34" charset="-120"/>
+                <a:latin typeface="Cambria" pitchFamily="34" charset="0"/>
+                <a:ea typeface="Cambria" pitchFamily="34" charset="-122"/>
+                <a:cs typeface="Cambria" pitchFamily="34" charset="-120"/>
               </a:rPr>
               <a:t>Academic supervisor: </a:t>
             </a:r>
@@ -3059,9 +3062,9 @@
                 <a:solidFill>
                   <a:schemeClr val="bg1"/>
                 </a:solidFill>
-                <a:latin typeface="Times New Roman" pitchFamily="34" charset="0"/>
-                <a:ea typeface="Times New Roman" pitchFamily="34" charset="-122"/>
-                <a:cs typeface="Times New Roman" pitchFamily="34" charset="-120"/>
+                <a:latin typeface="Cambria" pitchFamily="34" charset="0"/>
+                <a:ea typeface="Cambria" pitchFamily="34" charset="-122"/>
+                <a:cs typeface="Cambria" pitchFamily="34" charset="-120"/>
               </a:rPr>
               <a:t>Mr. TEMATEU KEVIN</a:t>
             </a:r>
@@ -3079,9 +3082,9 @@
                 <a:solidFill>
                   <a:schemeClr val="bg1"/>
                 </a:solidFill>
-                <a:latin typeface="Times New Roman" pitchFamily="34" charset="0"/>
-                <a:ea typeface="Times New Roman" pitchFamily="34" charset="-122"/>
-                <a:cs typeface="Times New Roman" pitchFamily="34" charset="-120"/>
+                <a:latin typeface="Cambria" pitchFamily="34" charset="0"/>
+                <a:ea typeface="Cambria" pitchFamily="34" charset="-122"/>
+                <a:cs typeface="Cambria" pitchFamily="34" charset="-120"/>
               </a:rPr>
               <a:t>Professional supervisor: </a:t>
             </a:r>
@@ -3096,9 +3099,9 @@
                 <a:solidFill>
                   <a:schemeClr val="bg1"/>
                 </a:solidFill>
-                <a:latin typeface="Times New Roman" pitchFamily="34" charset="0"/>
-                <a:ea typeface="Times New Roman" pitchFamily="34" charset="-122"/>
-                <a:cs typeface="Times New Roman" pitchFamily="34" charset="-120"/>
+                <a:latin typeface="Cambria" pitchFamily="34" charset="0"/>
+                <a:ea typeface="Cambria" pitchFamily="34" charset="-122"/>
+                <a:cs typeface="Cambria" pitchFamily="34" charset="-120"/>
               </a:rPr>
               <a:t>Engr. MBUN GODLOVE MBUN</a:t>
             </a:r>
@@ -3116,9 +3119,9 @@
                 <a:solidFill>
                   <a:schemeClr val="bg1"/>
                 </a:solidFill>
-                <a:latin typeface="Times New Roman" pitchFamily="34" charset="0"/>
-                <a:ea typeface="Times New Roman" pitchFamily="34" charset="-122"/>
-                <a:cs typeface="Times New Roman" pitchFamily="34" charset="-120"/>
+                <a:latin typeface="Cambria" pitchFamily="34" charset="0"/>
+                <a:ea typeface="Cambria" pitchFamily="34" charset="-122"/>
+                <a:cs typeface="Cambria" pitchFamily="34" charset="-120"/>
               </a:rPr>
               <a:t>Academic year: </a:t>
             </a:r>
@@ -3133,9 +3136,9 @@
                 <a:solidFill>
                   <a:schemeClr val="bg1"/>
                 </a:solidFill>
-                <a:latin typeface="Times New Roman" pitchFamily="34" charset="0"/>
-                <a:ea typeface="Times New Roman" pitchFamily="34" charset="-122"/>
-                <a:cs typeface="Times New Roman" pitchFamily="34" charset="-120"/>
+                <a:latin typeface="Cambria" pitchFamily="34" charset="0"/>
+                <a:ea typeface="Cambria" pitchFamily="34" charset="-122"/>
+                <a:cs typeface="Cambria" pitchFamily="34" charset="-120"/>
               </a:rPr>
               <a:t>2026–2027</a:t>
             </a:r>
@@ -3172,9 +3175,9 @@
                 <a:solidFill>
                   <a:schemeClr val="bg1"/>
                 </a:solidFill>
-                <a:latin typeface="Times New Roman" pitchFamily="34" charset="0"/>
-                <a:ea typeface="Times New Roman" pitchFamily="34" charset="-122"/>
-                <a:cs typeface="Times New Roman" pitchFamily="34" charset="-120"/>
+                <a:latin typeface="Cambria" pitchFamily="34" charset="0"/>
+                <a:ea typeface="Cambria" pitchFamily="34" charset="-122"/>
+                <a:cs typeface="Cambria" pitchFamily="34" charset="-120"/>
               </a:rPr>
               <a:t>ExamGrade AI</a:t>
             </a:r>
@@ -3209,7 +3212,7 @@
             <a:r>
               <a:rPr lang="en-US" sz="1500" i="1" dirty="0">
                 <a:solidFill>
-                  <a:schemeClr val="bg1"/>
+                  <a:schemeClr val="accent1"/>
                 </a:solidFill>
               </a:rPr>
               <a:t>The AI proposes, the teacher decides</a:t>
@@ -3274,6 +3277,9 @@
                 <a:solidFill>
                   <a:schemeClr val="bg1"/>
                 </a:solidFill>
+                <a:latin typeface="Cambria" pitchFamily="34" charset="0"/>
+                <a:ea typeface="Cambria" pitchFamily="34" charset="-122"/>
+                <a:cs typeface="Cambria" pitchFamily="34" charset="-120"/>
               </a:rPr>
               <a:t>SYSTEM DESIGN: USE CASE DIAGRAM</a:t>
             </a:r>
@@ -3302,14 +3308,14 @@
           </a:solidFill>
           <a:ln w="9525">
             <a:solidFill>
-              <a:schemeClr val="accent4"/>
+              <a:srgbClr val="D5DCE8"/>
             </a:solidFill>
             <a:prstDash val="solid"/>
           </a:ln>
           <a:effectLst>
             <a:outerShdw sx="100000" sy="100000" kx="0" ky="0" algn="bl" rotWithShape="0" blurRad="76200" dist="25400" dir="5400000">
-              <a:srgbClr val="8B0000">
-                <a:alpha val="12000"/>
+              <a:srgbClr val="1F3864">
+                <a:alpha val="10000"/>
               </a:srgbClr>
             </a:outerShdw>
           </a:effectLst>
@@ -3360,14 +3366,14 @@
           </a:solidFill>
           <a:ln w="9525">
             <a:solidFill>
-              <a:schemeClr val="accent4"/>
+              <a:srgbClr val="D5DCE8"/>
             </a:solidFill>
             <a:prstDash val="solid"/>
           </a:ln>
           <a:effectLst>
             <a:outerShdw sx="100000" sy="100000" kx="0" ky="0" algn="bl" rotWithShape="0" blurRad="76200" dist="25400" dir="5400000">
-              <a:srgbClr val="8B0000">
-                <a:alpha val="12000"/>
+              <a:srgbClr val="1F3864">
+                <a:alpha val="10000"/>
               </a:srgbClr>
             </a:outerShdw>
           </a:effectLst>
@@ -3388,7 +3394,7 @@
             <a:avLst/>
           </a:prstGeom>
           <a:solidFill>
-            <a:schemeClr val="accent1"/>
+            <a:schemeClr val="tx2"/>
           </a:solidFill>
           <a:ln/>
         </p:spPr>
@@ -3444,7 +3450,7 @@
             <a:r>
               <a:rPr lang="en-US" sz="1400" b="1" dirty="0">
                 <a:solidFill>
-                  <a:schemeClr val="accent2"/>
+                  <a:schemeClr val="tx2"/>
                 </a:solidFill>
               </a:rPr>
               <a:t>Student</a:t>
@@ -3488,14 +3494,14 @@
           </a:solidFill>
           <a:ln w="9525">
             <a:solidFill>
-              <a:schemeClr val="accent4"/>
+              <a:srgbClr val="D5DCE8"/>
             </a:solidFill>
             <a:prstDash val="solid"/>
           </a:ln>
           <a:effectLst>
             <a:outerShdw sx="100000" sy="100000" kx="0" ky="0" algn="bl" rotWithShape="0" blurRad="76200" dist="25400" dir="5400000">
-              <a:srgbClr val="8B0000">
-                <a:alpha val="12000"/>
+              <a:srgbClr val="1F3864">
+                <a:alpha val="10000"/>
               </a:srgbClr>
             </a:outerShdw>
           </a:effectLst>
@@ -3516,7 +3522,7 @@
             <a:avLst/>
           </a:prstGeom>
           <a:solidFill>
-            <a:schemeClr val="accent1"/>
+            <a:schemeClr val="tx2"/>
           </a:solidFill>
           <a:ln/>
         </p:spPr>
@@ -3572,7 +3578,7 @@
             <a:r>
               <a:rPr lang="en-US" sz="1400" b="1" dirty="0">
                 <a:solidFill>
-                  <a:schemeClr val="accent2"/>
+                  <a:schemeClr val="tx2"/>
                 </a:solidFill>
               </a:rPr>
               <a:t>Teacher</a:t>
@@ -3616,14 +3622,14 @@
           </a:solidFill>
           <a:ln w="9525">
             <a:solidFill>
-              <a:schemeClr val="accent4"/>
+              <a:srgbClr val="D5DCE8"/>
             </a:solidFill>
             <a:prstDash val="solid"/>
           </a:ln>
           <a:effectLst>
             <a:outerShdw sx="100000" sy="100000" kx="0" ky="0" algn="bl" rotWithShape="0" blurRad="76200" dist="25400" dir="5400000">
-              <a:srgbClr val="8B0000">
-                <a:alpha val="12000"/>
+              <a:srgbClr val="1F3864">
+                <a:alpha val="10000"/>
               </a:srgbClr>
             </a:outerShdw>
           </a:effectLst>
@@ -3644,7 +3650,7 @@
             <a:avLst/>
           </a:prstGeom>
           <a:solidFill>
-            <a:schemeClr val="accent1"/>
+            <a:schemeClr val="tx2"/>
           </a:solidFill>
           <a:ln/>
         </p:spPr>
@@ -3700,7 +3706,7 @@
             <a:r>
               <a:rPr lang="en-US" sz="1400" b="1" dirty="0">
                 <a:solidFill>
-                  <a:schemeClr val="accent2"/>
+                  <a:schemeClr val="tx2"/>
                 </a:solidFill>
               </a:rPr>
               <a:t>Administrator</a:t>
@@ -3740,18 +3746,18 @@
             </a:avLst>
           </a:prstGeom>
           <a:solidFill>
-            <a:schemeClr val="accent5"/>
+            <a:schemeClr val="accent4"/>
           </a:solidFill>
           <a:ln w="9525">
             <a:solidFill>
-              <a:schemeClr val="accent4"/>
+              <a:srgbClr val="D5DCE8"/>
             </a:solidFill>
             <a:prstDash val="solid"/>
           </a:ln>
           <a:effectLst>
             <a:outerShdw sx="100000" sy="100000" kx="0" ky="0" algn="bl" rotWithShape="0" blurRad="76200" dist="25400" dir="5400000">
-              <a:srgbClr val="8B0000">
-                <a:alpha val="12000"/>
+              <a:srgbClr val="1F3864">
+                <a:alpha val="10000"/>
               </a:srgbClr>
             </a:outerShdw>
           </a:effectLst>
@@ -3828,7 +3834,7 @@
             <a:r>
               <a:rPr lang="en-US" sz="1400" b="1" dirty="0">
                 <a:solidFill>
-                  <a:schemeClr val="accent2"/>
+                  <a:schemeClr val="tx2"/>
                 </a:solidFill>
               </a:rPr>
               <a:t>Gemini (external system)</a:t>
@@ -3881,7 +3887,7 @@
             <a:lvl1pPr>
               <a:defRPr sz="1000">
                 <a:solidFill>
-                  <a:schemeClr val="accent2"/>
+                  <a:schemeClr val="tx2"/>
                 </a:solidFill>
               </a:defRPr>
             </a:lvl1pPr>
@@ -3952,6 +3958,9 @@
                 <a:solidFill>
                   <a:schemeClr val="bg1"/>
                 </a:solidFill>
+                <a:latin typeface="Cambria" pitchFamily="34" charset="0"/>
+                <a:ea typeface="Cambria" pitchFamily="34" charset="-122"/>
+                <a:cs typeface="Cambria" pitchFamily="34" charset="-120"/>
               </a:rPr>
               <a:t>HOW THE AI GRADES, AND HOW THE PLATFORM STAYS SECURE</a:t>
             </a:r>
@@ -3980,14 +3989,14 @@
           </a:solidFill>
           <a:ln w="9525">
             <a:solidFill>
-              <a:schemeClr val="accent4"/>
+              <a:srgbClr val="D5DCE8"/>
             </a:solidFill>
             <a:prstDash val="solid"/>
           </a:ln>
           <a:effectLst>
             <a:outerShdw sx="100000" sy="100000" kx="0" ky="0" algn="bl" rotWithShape="0" blurRad="76200" dist="25400" dir="5400000">
-              <a:srgbClr val="8B0000">
-                <a:alpha val="12000"/>
+              <a:srgbClr val="1F3864">
+                <a:alpha val="10000"/>
               </a:srgbClr>
             </a:outerShdw>
           </a:effectLst>
@@ -4032,7 +4041,7 @@
             <a:avLst/>
           </a:prstGeom>
           <a:solidFill>
-            <a:schemeClr val="accent1"/>
+            <a:schemeClr val="tx2"/>
           </a:solidFill>
           <a:ln/>
         </p:spPr>
@@ -4100,7 +4109,7 @@
             <a:r>
               <a:rPr lang="en-US" sz="1400" b="1" dirty="0">
                 <a:solidFill>
-                  <a:schemeClr val="accent2"/>
+                  <a:schemeClr val="tx2"/>
                 </a:solidFill>
               </a:rPr>
               <a:t>Hardened prompt</a:t>
@@ -4138,7 +4147,7 @@
             <a:avLst/>
           </a:prstGeom>
           <a:solidFill>
-            <a:schemeClr val="accent1"/>
+            <a:schemeClr val="tx2"/>
           </a:solidFill>
           <a:ln/>
         </p:spPr>
@@ -4206,7 +4215,7 @@
             <a:r>
               <a:rPr lang="en-US" sz="1400" b="1" dirty="0">
                 <a:solidFill>
-                  <a:schemeClr val="accent2"/>
+                  <a:schemeClr val="tx2"/>
                 </a:solidFill>
               </a:rPr>
               <a:t>Server-side checks</a:t>
@@ -4244,7 +4253,7 @@
             <a:avLst/>
           </a:prstGeom>
           <a:solidFill>
-            <a:schemeClr val="accent1"/>
+            <a:schemeClr val="accent2"/>
           </a:solidFill>
           <a:ln/>
         </p:spPr>
@@ -4312,7 +4321,7 @@
             <a:r>
               <a:rPr lang="en-US" sz="1400" b="1" dirty="0">
                 <a:solidFill>
-                  <a:schemeClr val="accent2"/>
+                  <a:schemeClr val="tx2"/>
                 </a:solidFill>
               </a:rPr>
               <a:t>Teacher decides</a:t>
@@ -4352,18 +4361,18 @@
             </a:avLst>
           </a:prstGeom>
           <a:solidFill>
-            <a:schemeClr val="accent5"/>
+            <a:schemeClr val="accent4"/>
           </a:solidFill>
           <a:ln w="9525">
             <a:solidFill>
-              <a:schemeClr val="accent4"/>
+              <a:srgbClr val="D5DCE8"/>
             </a:solidFill>
             <a:prstDash val="solid"/>
           </a:ln>
           <a:effectLst>
             <a:outerShdw sx="100000" sy="100000" kx="0" ky="0" algn="bl" rotWithShape="0" blurRad="76200" dist="25400" dir="5400000">
-              <a:srgbClr val="8B0000">
-                <a:alpha val="12000"/>
+              <a:srgbClr val="1F3864">
+                <a:alpha val="10000"/>
               </a:srgbClr>
             </a:outerShdw>
           </a:effectLst>
@@ -4440,7 +4449,7 @@
             <a:r>
               <a:rPr lang="en-US" sz="1300" b="1" dirty="0">
                 <a:solidFill>
-                  <a:schemeClr val="accent2"/>
+                  <a:schemeClr val="tx2"/>
                 </a:solidFill>
               </a:rPr>
               <a:t>Prompt injection</a:t>
@@ -4484,14 +4493,14 @@
           </a:solidFill>
           <a:ln w="9525">
             <a:solidFill>
-              <a:schemeClr val="accent4"/>
+              <a:srgbClr val="D5DCE8"/>
             </a:solidFill>
             <a:prstDash val="solid"/>
           </a:ln>
           <a:effectLst>
             <a:outerShdw sx="100000" sy="100000" kx="0" ky="0" algn="bl" rotWithShape="0" blurRad="76200" dist="25400" dir="5400000">
-              <a:srgbClr val="8B0000">
-                <a:alpha val="12000"/>
+              <a:srgbClr val="1F3864">
+                <a:alpha val="10000"/>
               </a:srgbClr>
             </a:outerShdw>
           </a:effectLst>
@@ -4512,7 +4521,7 @@
             <a:avLst/>
           </a:prstGeom>
           <a:solidFill>
-            <a:schemeClr val="accent1"/>
+            <a:schemeClr val="tx2"/>
           </a:solidFill>
           <a:ln/>
         </p:spPr>
@@ -4568,7 +4577,7 @@
             <a:r>
               <a:rPr lang="en-US" sz="1300" b="1" dirty="0">
                 <a:solidFill>
-                  <a:schemeClr val="accent2"/>
+                  <a:schemeClr val="tx2"/>
                 </a:solidFill>
               </a:rPr>
               <a:t>Password theft</a:t>
@@ -4612,14 +4621,14 @@
           </a:solidFill>
           <a:ln w="9525">
             <a:solidFill>
-              <a:schemeClr val="accent4"/>
+              <a:srgbClr val="D5DCE8"/>
             </a:solidFill>
             <a:prstDash val="solid"/>
           </a:ln>
           <a:effectLst>
             <a:outerShdw sx="100000" sy="100000" kx="0" ky="0" algn="bl" rotWithShape="0" blurRad="76200" dist="25400" dir="5400000">
-              <a:srgbClr val="8B0000">
-                <a:alpha val="12000"/>
+              <a:srgbClr val="1F3864">
+                <a:alpha val="10000"/>
               </a:srgbClr>
             </a:outerShdw>
           </a:effectLst>
@@ -4640,7 +4649,7 @@
             <a:avLst/>
           </a:prstGeom>
           <a:solidFill>
-            <a:schemeClr val="accent1"/>
+            <a:schemeClr val="tx2"/>
           </a:solidFill>
           <a:ln/>
         </p:spPr>
@@ -4696,7 +4705,7 @@
             <a:r>
               <a:rPr lang="en-US" sz="1300" b="1" dirty="0">
                 <a:solidFill>
-                  <a:schemeClr val="accent2"/>
+                  <a:schemeClr val="tx2"/>
                 </a:solidFill>
               </a:rPr>
               <a:t>Stolen token</a:t>
@@ -4740,14 +4749,14 @@
           </a:solidFill>
           <a:ln w="9525">
             <a:solidFill>
-              <a:schemeClr val="accent4"/>
+              <a:srgbClr val="D5DCE8"/>
             </a:solidFill>
             <a:prstDash val="solid"/>
           </a:ln>
           <a:effectLst>
             <a:outerShdw sx="100000" sy="100000" kx="0" ky="0" algn="bl" rotWithShape="0" blurRad="76200" dist="25400" dir="5400000">
-              <a:srgbClr val="8B0000">
-                <a:alpha val="12000"/>
+              <a:srgbClr val="1F3864">
+                <a:alpha val="10000"/>
               </a:srgbClr>
             </a:outerShdw>
           </a:effectLst>
@@ -4768,7 +4777,7 @@
             <a:avLst/>
           </a:prstGeom>
           <a:solidFill>
-            <a:schemeClr val="accent1"/>
+            <a:schemeClr val="tx2"/>
           </a:solidFill>
           <a:ln/>
         </p:spPr>
@@ -4824,7 +4833,7 @@
             <a:r>
               <a:rPr lang="en-US" sz="1300" b="1" dirty="0">
                 <a:solidFill>
-                  <a:schemeClr val="accent2"/>
+                  <a:schemeClr val="tx2"/>
                 </a:solidFill>
               </a:rPr>
               <a:t>Brute force</a:t>
@@ -4868,14 +4877,14 @@
           </a:solidFill>
           <a:ln w="9525">
             <a:solidFill>
-              <a:schemeClr val="accent4"/>
+              <a:srgbClr val="D5DCE8"/>
             </a:solidFill>
             <a:prstDash val="solid"/>
           </a:ln>
           <a:effectLst>
             <a:outerShdw sx="100000" sy="100000" kx="0" ky="0" algn="bl" rotWithShape="0" blurRad="76200" dist="25400" dir="5400000">
-              <a:srgbClr val="8B0000">
-                <a:alpha val="12000"/>
+              <a:srgbClr val="1F3864">
+                <a:alpha val="10000"/>
               </a:srgbClr>
             </a:outerShdw>
           </a:effectLst>
@@ -4896,7 +4905,7 @@
             <a:avLst/>
           </a:prstGeom>
           <a:solidFill>
-            <a:schemeClr val="accent1"/>
+            <a:schemeClr val="tx2"/>
           </a:solidFill>
           <a:ln/>
         </p:spPr>
@@ -4952,7 +4961,7 @@
             <a:r>
               <a:rPr lang="en-US" sz="1300" b="1" dirty="0">
                 <a:solidFill>
-                  <a:schemeClr val="accent2"/>
+                  <a:schemeClr val="tx2"/>
                 </a:solidFill>
               </a:rPr>
               <a:t>NoSQL injection</a:t>
@@ -4996,14 +5005,14 @@
           </a:solidFill>
           <a:ln w="9525">
             <a:solidFill>
-              <a:schemeClr val="accent4"/>
+              <a:srgbClr val="D5DCE8"/>
             </a:solidFill>
             <a:prstDash val="solid"/>
           </a:ln>
           <a:effectLst>
             <a:outerShdw sx="100000" sy="100000" kx="0" ky="0" algn="bl" rotWithShape="0" blurRad="76200" dist="25400" dir="5400000">
-              <a:srgbClr val="8B0000">
-                <a:alpha val="12000"/>
+              <a:srgbClr val="1F3864">
+                <a:alpha val="10000"/>
               </a:srgbClr>
             </a:outerShdw>
           </a:effectLst>
@@ -5024,7 +5033,7 @@
             <a:avLst/>
           </a:prstGeom>
           <a:solidFill>
-            <a:schemeClr val="accent1"/>
+            <a:schemeClr val="tx2"/>
           </a:solidFill>
           <a:ln/>
         </p:spPr>
@@ -5080,7 +5089,7 @@
             <a:r>
               <a:rPr lang="en-US" sz="1300" b="1" dirty="0">
                 <a:solidFill>
-                  <a:schemeClr val="accent2"/>
+                  <a:schemeClr val="tx2"/>
                 </a:solidFill>
               </a:rPr>
               <a:t>Privilege escalation</a:t>
@@ -5124,14 +5133,14 @@
           </a:solidFill>
           <a:ln w="9525">
             <a:solidFill>
-              <a:schemeClr val="accent4"/>
+              <a:srgbClr val="D5DCE8"/>
             </a:solidFill>
             <a:prstDash val="solid"/>
           </a:ln>
           <a:effectLst>
             <a:outerShdw sx="100000" sy="100000" kx="0" ky="0" algn="bl" rotWithShape="0" blurRad="76200" dist="25400" dir="5400000">
-              <a:srgbClr val="8B0000">
-                <a:alpha val="12000"/>
+              <a:srgbClr val="1F3864">
+                <a:alpha val="10000"/>
               </a:srgbClr>
             </a:outerShdw>
           </a:effectLst>
@@ -5152,7 +5161,7 @@
             <a:avLst/>
           </a:prstGeom>
           <a:solidFill>
-            <a:schemeClr val="accent1"/>
+            <a:schemeClr val="tx2"/>
           </a:solidFill>
           <a:ln/>
         </p:spPr>
@@ -5208,7 +5217,7 @@
             <a:r>
               <a:rPr lang="en-US" sz="1300" b="1" dirty="0">
                 <a:solidFill>
-                  <a:schemeClr val="accent2"/>
+                  <a:schemeClr val="tx2"/>
                 </a:solidFill>
               </a:rPr>
               <a:t>Answer leakage</a:t>
@@ -5252,14 +5261,14 @@
           </a:solidFill>
           <a:ln w="9525">
             <a:solidFill>
-              <a:schemeClr val="accent4"/>
+              <a:srgbClr val="D5DCE8"/>
             </a:solidFill>
             <a:prstDash val="solid"/>
           </a:ln>
           <a:effectLst>
             <a:outerShdw sx="100000" sy="100000" kx="0" ky="0" algn="bl" rotWithShape="0" blurRad="76200" dist="25400" dir="5400000">
-              <a:srgbClr val="8B0000">
-                <a:alpha val="12000"/>
+              <a:srgbClr val="1F3864">
+                <a:alpha val="10000"/>
               </a:srgbClr>
             </a:outerShdw>
           </a:effectLst>
@@ -5280,7 +5289,7 @@
             <a:avLst/>
           </a:prstGeom>
           <a:solidFill>
-            <a:schemeClr val="accent1"/>
+            <a:schemeClr val="tx2"/>
           </a:solidFill>
           <a:ln/>
         </p:spPr>
@@ -5336,7 +5345,7 @@
             <a:r>
               <a:rPr lang="en-US" sz="1300" b="1" dirty="0">
                 <a:solidFill>
-                  <a:schemeClr val="accent2"/>
+                  <a:schemeClr val="tx2"/>
                 </a:solidFill>
               </a:rPr>
               <a:t>Repudiation</a:t>
@@ -5389,7 +5398,7 @@
             <a:lvl1pPr>
               <a:defRPr sz="1000">
                 <a:solidFill>
-                  <a:schemeClr val="accent2"/>
+                  <a:schemeClr val="tx2"/>
                 </a:solidFill>
               </a:defRPr>
             </a:lvl1pPr>
@@ -5460,6 +5469,9 @@
                 <a:solidFill>
                   <a:schemeClr val="bg1"/>
                 </a:solidFill>
+                <a:latin typeface="Cambria" pitchFamily="34" charset="0"/>
+                <a:ea typeface="Cambria" pitchFamily="34" charset="-122"/>
+                <a:cs typeface="Cambria" pitchFamily="34" charset="-120"/>
               </a:rPr>
               <a:t>IMPLEMENTATION: THE PLATFORM IN USE</a:t>
             </a:r>
@@ -5488,14 +5500,14 @@
           </a:solidFill>
           <a:ln w="9525">
             <a:solidFill>
-              <a:schemeClr val="accent4"/>
+              <a:srgbClr val="D5DCE8"/>
             </a:solidFill>
             <a:prstDash val="solid"/>
           </a:ln>
           <a:effectLst>
             <a:outerShdw sx="100000" sy="100000" kx="0" ky="0" algn="bl" rotWithShape="0" blurRad="76200" dist="25400" dir="5400000">
-              <a:srgbClr val="8B0000">
-                <a:alpha val="12000"/>
+              <a:srgbClr val="1F3864">
+                <a:alpha val="10000"/>
               </a:srgbClr>
             </a:outerShdw>
           </a:effectLst>
@@ -5552,7 +5564,7 @@
             <a:r>
               <a:rPr lang="en-US" sz="1600" b="1" dirty="0">
                 <a:solidFill>
-                  <a:schemeClr val="accent2"/>
+                  <a:schemeClr val="tx2"/>
                 </a:solidFill>
               </a:rPr>
               <a:t>1. Exam builder</a:t>
@@ -5596,14 +5608,14 @@
           </a:solidFill>
           <a:ln w="9525">
             <a:solidFill>
-              <a:schemeClr val="accent4"/>
+              <a:srgbClr val="D5DCE8"/>
             </a:solidFill>
             <a:prstDash val="solid"/>
           </a:ln>
           <a:effectLst>
             <a:outerShdw sx="100000" sy="100000" kx="0" ky="0" algn="bl" rotWithShape="0" blurRad="76200" dist="25400" dir="5400000">
-              <a:srgbClr val="8B0000">
-                <a:alpha val="12000"/>
+              <a:srgbClr val="1F3864">
+                <a:alpha val="10000"/>
               </a:srgbClr>
             </a:outerShdw>
           </a:effectLst>
@@ -5660,7 +5672,7 @@
             <a:r>
               <a:rPr lang="en-US" sz="1600" b="1" dirty="0">
                 <a:solidFill>
-                  <a:schemeClr val="accent2"/>
+                  <a:schemeClr val="tx2"/>
                 </a:solidFill>
               </a:rPr>
               <a:t>2. Exam room</a:t>
@@ -5704,14 +5716,14 @@
           </a:solidFill>
           <a:ln w="9525">
             <a:solidFill>
-              <a:schemeClr val="accent4"/>
+              <a:srgbClr val="D5DCE8"/>
             </a:solidFill>
             <a:prstDash val="solid"/>
           </a:ln>
           <a:effectLst>
             <a:outerShdw sx="100000" sy="100000" kx="0" ky="0" algn="bl" rotWithShape="0" blurRad="76200" dist="25400" dir="5400000">
-              <a:srgbClr val="8B0000">
-                <a:alpha val="12000"/>
+              <a:srgbClr val="1F3864">
+                <a:alpha val="10000"/>
               </a:srgbClr>
             </a:outerShdw>
           </a:effectLst>
@@ -5768,7 +5780,7 @@
             <a:r>
               <a:rPr lang="en-US" sz="1600" b="1" dirty="0">
                 <a:solidFill>
-                  <a:schemeClr val="accent2"/>
+                  <a:schemeClr val="tx2"/>
                 </a:solidFill>
               </a:rPr>
               <a:t>3. Review console</a:t>
@@ -5812,14 +5824,14 @@
           </a:solidFill>
           <a:ln w="9525">
             <a:solidFill>
-              <a:schemeClr val="accent4"/>
+              <a:srgbClr val="D5DCE8"/>
             </a:solidFill>
             <a:prstDash val="solid"/>
           </a:ln>
           <a:effectLst>
             <a:outerShdw sx="100000" sy="100000" kx="0" ky="0" algn="bl" rotWithShape="0" blurRad="76200" dist="25400" dir="5400000">
-              <a:srgbClr val="8B0000">
-                <a:alpha val="12000"/>
+              <a:srgbClr val="1F3864">
+                <a:alpha val="10000"/>
               </a:srgbClr>
             </a:outerShdw>
           </a:effectLst>
@@ -5876,7 +5888,7 @@
             <a:r>
               <a:rPr lang="en-US" sz="1600" b="1" dirty="0">
                 <a:solidFill>
-                  <a:schemeClr val="accent2"/>
+                  <a:schemeClr val="tx2"/>
                 </a:solidFill>
               </a:rPr>
               <a:t>4. Statistics</a:t>
@@ -5929,7 +5941,7 @@
             <a:lvl1pPr>
               <a:defRPr sz="1000">
                 <a:solidFill>
-                  <a:schemeClr val="accent2"/>
+                  <a:schemeClr val="tx2"/>
                 </a:solidFill>
               </a:defRPr>
             </a:lvl1pPr>
@@ -6000,6 +6012,9 @@
                 <a:solidFill>
                   <a:schemeClr val="bg1"/>
                 </a:solidFill>
+                <a:latin typeface="Cambria" pitchFamily="34" charset="0"/>
+                <a:ea typeface="Cambria" pitchFamily="34" charset="-122"/>
+                <a:cs typeface="Cambria" pitchFamily="34" charset="-120"/>
               </a:rPr>
               <a:t>TESTS &amp; RESULTS</a:t>
             </a:r>
@@ -6028,14 +6043,14 @@
           </a:solidFill>
           <a:ln w="9525">
             <a:solidFill>
-              <a:schemeClr val="accent4"/>
+              <a:srgbClr val="D5DCE8"/>
             </a:solidFill>
             <a:prstDash val="solid"/>
           </a:ln>
           <a:effectLst>
             <a:outerShdw sx="100000" sy="100000" kx="0" ky="0" algn="bl" rotWithShape="0" blurRad="76200" dist="25400" dir="5400000">
-              <a:srgbClr val="8B0000">
-                <a:alpha val="12000"/>
+              <a:srgbClr val="1F3864">
+                <a:alpha val="10000"/>
               </a:srgbClr>
             </a:outerShdw>
           </a:effectLst>
@@ -6068,7 +6083,7 @@
             <a:r>
               <a:rPr lang="en-US" sz="3200" b="1" dirty="0">
                 <a:solidFill>
-                  <a:schemeClr val="accent1"/>
+                  <a:schemeClr val="tx2"/>
                 </a:solidFill>
               </a:rPr>
               <a:t>53</a:t>
@@ -6134,14 +6149,14 @@
           </a:solidFill>
           <a:ln w="9525">
             <a:solidFill>
-              <a:schemeClr val="accent4"/>
+              <a:srgbClr val="D5DCE8"/>
             </a:solidFill>
             <a:prstDash val="solid"/>
           </a:ln>
           <a:effectLst>
             <a:outerShdw sx="100000" sy="100000" kx="0" ky="0" algn="bl" rotWithShape="0" blurRad="76200" dist="25400" dir="5400000">
-              <a:srgbClr val="8B0000">
-                <a:alpha val="12000"/>
+              <a:srgbClr val="1F3864">
+                <a:alpha val="10000"/>
               </a:srgbClr>
             </a:outerShdw>
           </a:effectLst>
@@ -6174,7 +6189,7 @@
             <a:r>
               <a:rPr lang="en-US" sz="3200" b="1" dirty="0">
                 <a:solidFill>
-                  <a:schemeClr val="accent1"/>
+                  <a:schemeClr val="tx2"/>
                 </a:solidFill>
               </a:rPr>
               <a:t>12 / 12</a:t>
@@ -6240,14 +6255,14 @@
           </a:solidFill>
           <a:ln w="9525">
             <a:solidFill>
-              <a:schemeClr val="accent4"/>
+              <a:srgbClr val="D5DCE8"/>
             </a:solidFill>
             <a:prstDash val="solid"/>
           </a:ln>
           <a:effectLst>
             <a:outerShdw sx="100000" sy="100000" kx="0" ky="0" algn="bl" rotWithShape="0" blurRad="76200" dist="25400" dir="5400000">
-              <a:srgbClr val="8B0000">
-                <a:alpha val="12000"/>
+              <a:srgbClr val="1F3864">
+                <a:alpha val="10000"/>
               </a:srgbClr>
             </a:outerShdw>
           </a:effectLst>
@@ -6280,7 +6295,7 @@
             <a:r>
               <a:rPr lang="en-US" sz="3200" b="1" dirty="0">
                 <a:solidFill>
-                  <a:schemeClr val="accent1"/>
+                  <a:schemeClr val="tx2"/>
                 </a:solidFill>
               </a:rPr>
               <a:t>93.33 %</a:t>
@@ -6346,14 +6361,14 @@
           </a:solidFill>
           <a:ln w="9525">
             <a:solidFill>
-              <a:schemeClr val="accent4"/>
+              <a:srgbClr val="D5DCE8"/>
             </a:solidFill>
             <a:prstDash val="solid"/>
           </a:ln>
           <a:effectLst>
             <a:outerShdw sx="100000" sy="100000" kx="0" ky="0" algn="bl" rotWithShape="0" blurRad="76200" dist="25400" dir="5400000">
-              <a:srgbClr val="8B0000">
-                <a:alpha val="12000"/>
+              <a:srgbClr val="1F3864">
+                <a:alpha val="10000"/>
               </a:srgbClr>
             </a:outerShdw>
           </a:effectLst>
@@ -6392,18 +6407,18 @@
             </a:avLst>
           </a:prstGeom>
           <a:solidFill>
-            <a:schemeClr val="accent5"/>
+            <a:schemeClr val="accent4"/>
           </a:solidFill>
           <a:ln w="9525">
             <a:solidFill>
-              <a:schemeClr val="accent4"/>
+              <a:srgbClr val="D5DCE8"/>
             </a:solidFill>
             <a:prstDash val="solid"/>
           </a:ln>
           <a:effectLst>
             <a:outerShdw sx="100000" sy="100000" kx="0" ky="0" algn="bl" rotWithShape="0" blurRad="76200" dist="25400" dir="5400000">
-              <a:srgbClr val="8B0000">
-                <a:alpha val="12000"/>
+              <a:srgbClr val="1F3864">
+                <a:alpha val="10000"/>
               </a:srgbClr>
             </a:outerShdw>
           </a:effectLst>
@@ -6436,7 +6451,7 @@
             <a:r>
               <a:rPr lang="en-US" sz="1600" b="1" dirty="0">
                 <a:solidFill>
-                  <a:schemeClr val="accent2"/>
+                  <a:schemeClr val="tx2"/>
                 </a:solidFill>
               </a:rPr>
               <a:t>Prompt injection test</a:t>
@@ -6496,7 +6511,7 @@
             <a:r>
               <a:rPr lang="en-US" sz="3600" b="1" dirty="0">
                 <a:solidFill>
-                  <a:schemeClr val="accent1"/>
+                  <a:schemeClr val="accent2"/>
                 </a:solidFill>
               </a:rPr>
               <a:t>0 / 5</a:t>
@@ -6607,7 +6622,7 @@
             <a:lvl1pPr>
               <a:defRPr sz="1000">
                 <a:solidFill>
-                  <a:schemeClr val="accent2"/>
+                  <a:schemeClr val="tx2"/>
                 </a:solidFill>
               </a:defRPr>
             </a:lvl1pPr>
@@ -6678,6 +6693,9 @@
                 <a:solidFill>
                   <a:schemeClr val="bg1"/>
                 </a:solidFill>
+                <a:latin typeface="Cambria" pitchFamily="34" charset="0"/>
+                <a:ea typeface="Cambria" pitchFamily="34" charset="-122"/>
+                <a:cs typeface="Cambria" pitchFamily="34" charset="-120"/>
               </a:rPr>
               <a:t>LIMITS, FUTURE PERSPECTIVES &amp; GENERAL CONCLUSION</a:t>
             </a:r>
@@ -6868,7 +6886,7 @@
             <a:avLst/>
           </a:prstGeom>
           <a:solidFill>
-            <a:schemeClr val="accent1"/>
+            <a:schemeClr val="accent2"/>
           </a:solidFill>
           <a:ln/>
         </p:spPr>
@@ -7036,11 +7054,11 @@
             <a:avLst/>
           </a:prstGeom>
           <a:solidFill>
-            <a:schemeClr val="accent5"/>
+            <a:schemeClr val="bg2"/>
           </a:solidFill>
           <a:ln w="12700">
             <a:solidFill>
-              <a:schemeClr val="accent1"/>
+              <a:schemeClr val="tx2"/>
             </a:solidFill>
             <a:prstDash val="solid"/>
           </a:ln>
@@ -7073,7 +7091,7 @@
             <a:r>
               <a:rPr lang="en-US" sz="1700" b="1" dirty="0">
                 <a:solidFill>
-                  <a:schemeClr val="accent2"/>
+                  <a:schemeClr val="tx2"/>
                 </a:solidFill>
               </a:rPr>
               <a:t>General conclusion</a:t>
@@ -7148,7 +7166,7 @@
             <a:lvl1pPr>
               <a:defRPr sz="1000">
                 <a:solidFill>
-                  <a:schemeClr val="accent2"/>
+                  <a:schemeClr val="tx2"/>
                 </a:solidFill>
               </a:defRPr>
             </a:lvl1pPr>
@@ -7203,7 +7221,7 @@
             <a:avLst/>
           </a:prstGeom>
           <a:solidFill>
-            <a:schemeClr val="accent3"/>
+            <a:srgbClr val="172B4D"/>
           </a:solidFill>
           <a:ln/>
         </p:spPr>
@@ -7223,7 +7241,7 @@
             <a:avLst/>
           </a:prstGeom>
           <a:solidFill>
-            <a:schemeClr val="accent1"/>
+            <a:srgbClr val="2A4A80"/>
           </a:solidFill>
           <a:ln/>
         </p:spPr>
@@ -7268,7 +7286,7 @@
             <a:avLst/>
           </a:prstGeom>
           <a:solidFill>
-            <a:schemeClr val="accent4"/>
+            <a:schemeClr val="accent1"/>
           </a:solidFill>
           <a:ln w="12700">
             <a:solidFill>
@@ -7293,7 +7311,7 @@
             <a:avLst/>
           </a:prstGeom>
           <a:solidFill>
-            <a:schemeClr val="accent5"/>
+            <a:schemeClr val="accent2"/>
           </a:solidFill>
           <a:ln w="12700">
             <a:solidFill>
@@ -7357,9 +7375,9 @@
                 <a:solidFill>
                   <a:schemeClr val="bg1"/>
                 </a:solidFill>
-                <a:latin typeface="Times New Roman" pitchFamily="34" charset="0"/>
-                <a:ea typeface="Times New Roman" pitchFamily="34" charset="-122"/>
-                <a:cs typeface="Times New Roman" pitchFamily="34" charset="-120"/>
+                <a:latin typeface="Cambria" pitchFamily="34" charset="0"/>
+                <a:ea typeface="Cambria" pitchFamily="34" charset="-122"/>
+                <a:cs typeface="Cambria" pitchFamily="34" charset="-120"/>
               </a:rPr>
               <a:t>THANK YOU!</a:t>
             </a:r>
@@ -7394,7 +7412,7 @@
             <a:r>
               <a:rPr lang="en-US" sz="2600" i="1" dirty="0">
                 <a:solidFill>
-                  <a:schemeClr val="accent4"/>
+                  <a:schemeClr val="accent1"/>
                 </a:solidFill>
               </a:rPr>
               <a:t>Questions?</a:t>
@@ -7420,7 +7438,7 @@
             </a:avLst>
           </a:prstGeom>
           <a:solidFill>
-            <a:schemeClr val="accent1"/>
+            <a:srgbClr val="2A4A80"/>
           </a:solidFill>
           <a:ln/>
         </p:spPr>
@@ -7478,7 +7496,7 @@
             </a:avLst>
           </a:prstGeom>
           <a:solidFill>
-            <a:schemeClr val="accent1"/>
+            <a:srgbClr val="2A4A80"/>
           </a:solidFill>
           <a:ln/>
         </p:spPr>
@@ -7536,7 +7554,7 @@
             </a:avLst>
           </a:prstGeom>
           <a:solidFill>
-            <a:schemeClr val="accent1"/>
+            <a:srgbClr val="2A4A80"/>
           </a:solidFill>
           <a:ln/>
         </p:spPr>
@@ -7711,6 +7729,9 @@
                 <a:solidFill>
                   <a:schemeClr val="bg1"/>
                 </a:solidFill>
+                <a:latin typeface="Cambria" pitchFamily="34" charset="0"/>
+                <a:ea typeface="Cambria" pitchFamily="34" charset="-122"/>
+                <a:cs typeface="Cambria" pitchFamily="34" charset="-120"/>
               </a:rPr>
               <a:t>OUTLINE</a:t>
             </a:r>
@@ -7739,14 +7760,14 @@
           </a:solidFill>
           <a:ln w="9525">
             <a:solidFill>
-              <a:schemeClr val="accent4"/>
+              <a:srgbClr val="D5DCE8"/>
             </a:solidFill>
             <a:prstDash val="solid"/>
           </a:ln>
           <a:effectLst>
             <a:outerShdw sx="100000" sy="100000" kx="0" ky="0" algn="bl" rotWithShape="0" blurRad="76200" dist="25400" dir="5400000">
-              <a:srgbClr val="8B0000">
-                <a:alpha val="12000"/>
+              <a:srgbClr val="1F3864">
+                <a:alpha val="10000"/>
               </a:srgbClr>
             </a:outerShdw>
           </a:effectLst>
@@ -7767,7 +7788,7 @@
             <a:avLst/>
           </a:prstGeom>
           <a:solidFill>
-            <a:schemeClr val="accent2"/>
+            <a:schemeClr val="tx2"/>
           </a:solidFill>
           <a:ln/>
         </p:spPr>
@@ -7865,14 +7886,14 @@
           </a:solidFill>
           <a:ln w="9525">
             <a:solidFill>
-              <a:schemeClr val="accent4"/>
+              <a:srgbClr val="D5DCE8"/>
             </a:solidFill>
             <a:prstDash val="solid"/>
           </a:ln>
           <a:effectLst>
             <a:outerShdw sx="100000" sy="100000" kx="0" ky="0" algn="bl" rotWithShape="0" blurRad="76200" dist="25400" dir="5400000">
-              <a:srgbClr val="8B0000">
-                <a:alpha val="12000"/>
+              <a:srgbClr val="1F3864">
+                <a:alpha val="10000"/>
               </a:srgbClr>
             </a:outerShdw>
           </a:effectLst>
@@ -7893,7 +7914,7 @@
             <a:avLst/>
           </a:prstGeom>
           <a:solidFill>
-            <a:schemeClr val="accent2"/>
+            <a:schemeClr val="tx2"/>
           </a:solidFill>
           <a:ln/>
         </p:spPr>
@@ -7991,14 +8012,14 @@
           </a:solidFill>
           <a:ln w="9525">
             <a:solidFill>
-              <a:schemeClr val="accent4"/>
+              <a:srgbClr val="D5DCE8"/>
             </a:solidFill>
             <a:prstDash val="solid"/>
           </a:ln>
           <a:effectLst>
             <a:outerShdw sx="100000" sy="100000" kx="0" ky="0" algn="bl" rotWithShape="0" blurRad="76200" dist="25400" dir="5400000">
-              <a:srgbClr val="8B0000">
-                <a:alpha val="12000"/>
+              <a:srgbClr val="1F3864">
+                <a:alpha val="10000"/>
               </a:srgbClr>
             </a:outerShdw>
           </a:effectLst>
@@ -8019,7 +8040,7 @@
             <a:avLst/>
           </a:prstGeom>
           <a:solidFill>
-            <a:schemeClr val="accent2"/>
+            <a:schemeClr val="tx2"/>
           </a:solidFill>
           <a:ln/>
         </p:spPr>
@@ -8117,14 +8138,14 @@
           </a:solidFill>
           <a:ln w="9525">
             <a:solidFill>
-              <a:schemeClr val="accent4"/>
+              <a:srgbClr val="D5DCE8"/>
             </a:solidFill>
             <a:prstDash val="solid"/>
           </a:ln>
           <a:effectLst>
             <a:outerShdw sx="100000" sy="100000" kx="0" ky="0" algn="bl" rotWithShape="0" blurRad="76200" dist="25400" dir="5400000">
-              <a:srgbClr val="8B0000">
-                <a:alpha val="12000"/>
+              <a:srgbClr val="1F3864">
+                <a:alpha val="10000"/>
               </a:srgbClr>
             </a:outerShdw>
           </a:effectLst>
@@ -8145,7 +8166,7 @@
             <a:avLst/>
           </a:prstGeom>
           <a:solidFill>
-            <a:schemeClr val="accent2"/>
+            <a:schemeClr val="tx2"/>
           </a:solidFill>
           <a:ln/>
         </p:spPr>
@@ -8243,14 +8264,14 @@
           </a:solidFill>
           <a:ln w="9525">
             <a:solidFill>
-              <a:schemeClr val="accent4"/>
+              <a:srgbClr val="D5DCE8"/>
             </a:solidFill>
             <a:prstDash val="solid"/>
           </a:ln>
           <a:effectLst>
             <a:outerShdw sx="100000" sy="100000" kx="0" ky="0" algn="bl" rotWithShape="0" blurRad="76200" dist="25400" dir="5400000">
-              <a:srgbClr val="8B0000">
-                <a:alpha val="12000"/>
+              <a:srgbClr val="1F3864">
+                <a:alpha val="10000"/>
               </a:srgbClr>
             </a:outerShdw>
           </a:effectLst>
@@ -8271,7 +8292,7 @@
             <a:avLst/>
           </a:prstGeom>
           <a:solidFill>
-            <a:schemeClr val="accent2"/>
+            <a:schemeClr val="tx2"/>
           </a:solidFill>
           <a:ln/>
         </p:spPr>
@@ -8369,14 +8390,14 @@
           </a:solidFill>
           <a:ln w="9525">
             <a:solidFill>
-              <a:schemeClr val="accent4"/>
+              <a:srgbClr val="D5DCE8"/>
             </a:solidFill>
             <a:prstDash val="solid"/>
           </a:ln>
           <a:effectLst>
             <a:outerShdw sx="100000" sy="100000" kx="0" ky="0" algn="bl" rotWithShape="0" blurRad="76200" dist="25400" dir="5400000">
-              <a:srgbClr val="8B0000">
-                <a:alpha val="12000"/>
+              <a:srgbClr val="1F3864">
+                <a:alpha val="10000"/>
               </a:srgbClr>
             </a:outerShdw>
           </a:effectLst>
@@ -8397,7 +8418,7 @@
             <a:avLst/>
           </a:prstGeom>
           <a:solidFill>
-            <a:schemeClr val="accent2"/>
+            <a:schemeClr val="tx2"/>
           </a:solidFill>
           <a:ln/>
         </p:spPr>
@@ -8504,7 +8525,7 @@
             <a:lvl1pPr>
               <a:defRPr sz="1000">
                 <a:solidFill>
-                  <a:schemeClr val="accent2"/>
+                  <a:schemeClr val="tx2"/>
                 </a:solidFill>
               </a:defRPr>
             </a:lvl1pPr>
@@ -8575,6 +8596,9 @@
                 <a:solidFill>
                   <a:schemeClr val="bg1"/>
                 </a:solidFill>
+                <a:latin typeface="Cambria" pitchFamily="34" charset="0"/>
+                <a:ea typeface="Cambria" pitchFamily="34" charset="-122"/>
+                <a:cs typeface="Cambria" pitchFamily="34" charset="-120"/>
               </a:rPr>
               <a:t>GENERAL INTRODUCTION</a:t>
             </a:r>
@@ -8609,7 +8633,7 @@
             <a:r>
               <a:rPr lang="en-US" sz="1800" b="1" dirty="0">
                 <a:solidFill>
-                  <a:schemeClr val="accent2"/>
+                  <a:schemeClr val="tx2"/>
                 </a:solidFill>
               </a:rPr>
               <a:t>Context</a:t>
@@ -8681,7 +8705,7 @@
             <a:r>
               <a:rPr lang="en-US" sz="1800" b="1" dirty="0">
                 <a:solidFill>
-                  <a:schemeClr val="accent2"/>
+                  <a:schemeClr val="tx2"/>
                 </a:solidFill>
               </a:rPr>
               <a:t>Central question</a:t>
@@ -8705,11 +8729,11 @@
             <a:avLst/>
           </a:prstGeom>
           <a:solidFill>
-            <a:schemeClr val="accent5"/>
+            <a:schemeClr val="bg2"/>
           </a:solidFill>
           <a:ln w="9525">
             <a:solidFill>
-              <a:schemeClr val="accent4"/>
+              <a:srgbClr val="D5DCE8"/>
             </a:solidFill>
             <a:prstDash val="solid"/>
           </a:ln>
@@ -8742,7 +8766,7 @@
             <a:r>
               <a:rPr lang="en-US" sz="1700" i="1" dirty="0">
                 <a:solidFill>
-                  <a:schemeClr val="accent2"/>
+                  <a:schemeClr val="tx2"/>
                 </a:solidFill>
               </a:rPr>
               <a:t>How can we build a secure exam platform where AI pre-grades every answer, including open ones, while the teacher keeps the final decision and the AI's reliability is measured?</a:t>
@@ -8778,7 +8802,7 @@
             <a:r>
               <a:rPr lang="en-US" sz="1800" b="1" dirty="0">
                 <a:solidFill>
-                  <a:schemeClr val="accent2"/>
+                  <a:schemeClr val="tx2"/>
                 </a:solidFill>
               </a:rPr>
               <a:t>Objectives</a:t>
@@ -8802,7 +8826,7 @@
             <a:avLst/>
           </a:prstGeom>
           <a:solidFill>
-            <a:schemeClr val="accent1"/>
+            <a:schemeClr val="tx2"/>
           </a:solidFill>
           <a:ln/>
         </p:spPr>
@@ -8858,7 +8882,7 @@
             <a:r>
               <a:rPr lang="en-US" sz="1400" b="1" dirty="0">
                 <a:solidFill>
-                  <a:schemeClr val="accent2"/>
+                  <a:schemeClr val="tx2"/>
                 </a:solidFill>
               </a:rPr>
               <a:t>Create exams</a:t>
@@ -8896,7 +8920,7 @@
             <a:avLst/>
           </a:prstGeom>
           <a:solidFill>
-            <a:schemeClr val="accent1"/>
+            <a:schemeClr val="tx2"/>
           </a:solidFill>
           <a:ln/>
         </p:spPr>
@@ -8952,7 +8976,7 @@
             <a:r>
               <a:rPr lang="en-US" sz="1400" b="1" dirty="0">
                 <a:solidFill>
-                  <a:schemeClr val="accent2"/>
+                  <a:schemeClr val="tx2"/>
                 </a:solidFill>
               </a:rPr>
               <a:t>Take exams safely</a:t>
@@ -8990,7 +9014,7 @@
             <a:avLst/>
           </a:prstGeom>
           <a:solidFill>
-            <a:schemeClr val="accent1"/>
+            <a:schemeClr val="tx2"/>
           </a:solidFill>
           <a:ln/>
         </p:spPr>
@@ -9046,7 +9070,7 @@
             <a:r>
               <a:rPr lang="en-US" sz="1400" b="1" dirty="0">
                 <a:solidFill>
-                  <a:schemeClr val="accent2"/>
+                  <a:schemeClr val="tx2"/>
                 </a:solidFill>
               </a:rPr>
               <a:t>Grade with AI</a:t>
@@ -9084,7 +9108,7 @@
             <a:avLst/>
           </a:prstGeom>
           <a:solidFill>
-            <a:schemeClr val="accent1"/>
+            <a:schemeClr val="tx2"/>
           </a:solidFill>
           <a:ln/>
         </p:spPr>
@@ -9140,7 +9164,7 @@
             <a:r>
               <a:rPr lang="en-US" sz="1400" b="1" dirty="0">
                 <a:solidFill>
-                  <a:schemeClr val="accent2"/>
+                  <a:schemeClr val="tx2"/>
                 </a:solidFill>
               </a:rPr>
               <a:t>Teacher decides</a:t>
@@ -9178,7 +9202,7 @@
             <a:avLst/>
           </a:prstGeom>
           <a:solidFill>
-            <a:schemeClr val="accent1"/>
+            <a:schemeClr val="tx2"/>
           </a:solidFill>
           <a:ln/>
         </p:spPr>
@@ -9234,7 +9258,7 @@
             <a:r>
               <a:rPr lang="en-US" sz="1400" b="1" dirty="0">
                 <a:solidFill>
-                  <a:schemeClr val="accent2"/>
+                  <a:schemeClr val="tx2"/>
                 </a:solidFill>
               </a:rPr>
               <a:t>Measure the AI</a:t>
@@ -9272,7 +9296,7 @@
             <a:avLst/>
           </a:prstGeom>
           <a:solidFill>
-            <a:schemeClr val="accent1"/>
+            <a:schemeClr val="tx2"/>
           </a:solidFill>
           <a:ln/>
         </p:spPr>
@@ -9328,7 +9352,7 @@
             <a:r>
               <a:rPr lang="en-US" sz="1400" b="1" dirty="0">
                 <a:solidFill>
-                  <a:schemeClr val="accent2"/>
+                  <a:schemeClr val="tx2"/>
                 </a:solidFill>
               </a:rPr>
               <a:t>Stay secure</a:t>
@@ -9381,7 +9405,7 @@
             <a:lvl1pPr>
               <a:defRPr sz="1000">
                 <a:solidFill>
-                  <a:schemeClr val="accent2"/>
+                  <a:schemeClr val="tx2"/>
                 </a:solidFill>
               </a:defRPr>
             </a:lvl1pPr>
@@ -9452,6 +9476,9 @@
                 <a:solidFill>
                   <a:schemeClr val="bg1"/>
                 </a:solidFill>
+                <a:latin typeface="Cambria" pitchFamily="34" charset="0"/>
+                <a:ea typeface="Cambria" pitchFamily="34" charset="-122"/>
+                <a:cs typeface="Cambria" pitchFamily="34" charset="-120"/>
               </a:rPr>
               <a:t>G&amp;C CREATIVE TECHNOLOGY &amp; INTERNSHIP</a:t>
             </a:r>
@@ -9474,7 +9501,7 @@
             <a:avLst/>
           </a:prstGeom>
           <a:solidFill>
-            <a:schemeClr val="accent2"/>
+            <a:schemeClr val="tx2"/>
           </a:solidFill>
           <a:ln/>
         </p:spPr>
@@ -9530,7 +9557,7 @@
             <a:avLst/>
           </a:prstGeom>
           <a:solidFill>
-            <a:schemeClr val="accent5"/>
+            <a:schemeClr val="bg2"/>
           </a:solidFill>
           <a:ln/>
         </p:spPr>
@@ -9586,7 +9613,7 @@
             <a:avLst/>
           </a:prstGeom>
           <a:solidFill>
-            <a:schemeClr val="accent2"/>
+            <a:schemeClr val="tx2"/>
           </a:solidFill>
           <a:ln/>
         </p:spPr>
@@ -9642,7 +9669,7 @@
             <a:avLst/>
           </a:prstGeom>
           <a:solidFill>
-            <a:schemeClr val="accent5"/>
+            <a:schemeClr val="bg2"/>
           </a:solidFill>
           <a:ln/>
         </p:spPr>
@@ -9698,7 +9725,7 @@
             <a:avLst/>
           </a:prstGeom>
           <a:solidFill>
-            <a:schemeClr val="accent2"/>
+            <a:schemeClr val="tx2"/>
           </a:solidFill>
           <a:ln/>
         </p:spPr>
@@ -9754,7 +9781,7 @@
             <a:avLst/>
           </a:prstGeom>
           <a:solidFill>
-            <a:schemeClr val="accent5"/>
+            <a:schemeClr val="bg2"/>
           </a:solidFill>
           <a:ln/>
         </p:spPr>
@@ -9810,7 +9837,7 @@
             <a:avLst/>
           </a:prstGeom>
           <a:solidFill>
-            <a:schemeClr val="accent2"/>
+            <a:schemeClr val="tx2"/>
           </a:solidFill>
           <a:ln/>
         </p:spPr>
@@ -9866,7 +9893,7 @@
             <a:avLst/>
           </a:prstGeom>
           <a:solidFill>
-            <a:schemeClr val="accent5"/>
+            <a:schemeClr val="bg2"/>
           </a:solidFill>
           <a:ln/>
         </p:spPr>
@@ -9922,7 +9949,7 @@
             <a:avLst/>
           </a:prstGeom>
           <a:solidFill>
-            <a:schemeClr val="accent2"/>
+            <a:schemeClr val="tx2"/>
           </a:solidFill>
           <a:ln/>
         </p:spPr>
@@ -9978,7 +10005,7 @@
             <a:avLst/>
           </a:prstGeom>
           <a:solidFill>
-            <a:schemeClr val="accent5"/>
+            <a:schemeClr val="bg2"/>
           </a:solidFill>
           <a:ln/>
         </p:spPr>
@@ -10040,14 +10067,14 @@
           </a:solidFill>
           <a:ln w="9525">
             <a:solidFill>
-              <a:schemeClr val="accent4"/>
+              <a:srgbClr val="D5DCE8"/>
             </a:solidFill>
             <a:prstDash val="solid"/>
           </a:ln>
           <a:effectLst>
             <a:outerShdw sx="100000" sy="100000" kx="0" ky="0" algn="bl" rotWithShape="0" blurRad="76200" dist="25400" dir="5400000">
-              <a:srgbClr val="8B0000">
-                <a:alpha val="12000"/>
+              <a:srgbClr val="1F3864">
+                <a:alpha val="10000"/>
               </a:srgbClr>
             </a:outerShdw>
           </a:effectLst>
@@ -10092,7 +10119,7 @@
             <a:avLst/>
           </a:prstGeom>
           <a:solidFill>
-            <a:schemeClr val="accent5"/>
+            <a:schemeClr val="bg2"/>
           </a:solidFill>
           <a:ln/>
         </p:spPr>
@@ -10162,7 +10189,7 @@
             <a:avLst/>
           </a:prstGeom>
           <a:solidFill>
-            <a:schemeClr val="accent5"/>
+            <a:schemeClr val="bg2"/>
           </a:solidFill>
           <a:ln/>
         </p:spPr>
@@ -10232,7 +10259,7 @@
             <a:avLst/>
           </a:prstGeom>
           <a:solidFill>
-            <a:schemeClr val="accent1"/>
+            <a:schemeClr val="accent2"/>
           </a:solidFill>
           <a:ln/>
         </p:spPr>
@@ -10317,7 +10344,7 @@
             <a:lvl1pPr>
               <a:defRPr sz="1000">
                 <a:solidFill>
-                  <a:schemeClr val="accent2"/>
+                  <a:schemeClr val="tx2"/>
                 </a:solidFill>
               </a:defRPr>
             </a:lvl1pPr>
@@ -10388,6 +10415,9 @@
                 <a:solidFill>
                   <a:schemeClr val="bg1"/>
                 </a:solidFill>
+                <a:latin typeface="Cambria" pitchFamily="34" charset="0"/>
+                <a:ea typeface="Cambria" pitchFamily="34" charset="-122"/>
+                <a:cs typeface="Cambria" pitchFamily="34" charset="-120"/>
               </a:rPr>
               <a:t>DIAGNOSTIC OF THE EXISTING SYSTEM</a:t>
             </a:r>
@@ -10416,14 +10446,14 @@
           </a:solidFill>
           <a:ln w="9525">
             <a:solidFill>
-              <a:schemeClr val="accent4"/>
+              <a:srgbClr val="D5DCE8"/>
             </a:solidFill>
             <a:prstDash val="solid"/>
           </a:ln>
           <a:effectLst>
             <a:outerShdw sx="100000" sy="100000" kx="0" ky="0" algn="bl" rotWithShape="0" blurRad="76200" dist="25400" dir="5400000">
-              <a:srgbClr val="8B0000">
-                <a:alpha val="12000"/>
+              <a:srgbClr val="1F3864">
+                <a:alpha val="10000"/>
               </a:srgbClr>
             </a:outerShdw>
           </a:effectLst>
@@ -10456,7 +10486,7 @@
             <a:r>
               <a:rPr lang="en-US" sz="3200" b="1" dirty="0">
                 <a:solidFill>
-                  <a:schemeClr val="accent1"/>
+                  <a:schemeClr val="tx2"/>
                 </a:solidFill>
               </a:rPr>
               <a:t>5 min</a:t>
@@ -10522,14 +10552,14 @@
           </a:solidFill>
           <a:ln w="9525">
             <a:solidFill>
-              <a:schemeClr val="accent4"/>
+              <a:srgbClr val="D5DCE8"/>
             </a:solidFill>
             <a:prstDash val="solid"/>
           </a:ln>
           <a:effectLst>
             <a:outerShdw sx="100000" sy="100000" kx="0" ky="0" algn="bl" rotWithShape="0" blurRad="76200" dist="25400" dir="5400000">
-              <a:srgbClr val="8B0000">
-                <a:alpha val="12000"/>
+              <a:srgbClr val="1F3864">
+                <a:alpha val="10000"/>
               </a:srgbClr>
             </a:outerShdw>
           </a:effectLst>
@@ -10562,7 +10592,7 @@
             <a:r>
               <a:rPr lang="en-US" sz="3200" b="1" dirty="0">
                 <a:solidFill>
-                  <a:schemeClr val="accent1"/>
+                  <a:schemeClr val="tx2"/>
                 </a:solidFill>
               </a:rPr>
               <a:t>8 h+</a:t>
@@ -10628,14 +10658,14 @@
           </a:solidFill>
           <a:ln w="9525">
             <a:solidFill>
-              <a:schemeClr val="accent4"/>
+              <a:srgbClr val="D5DCE8"/>
             </a:solidFill>
             <a:prstDash val="solid"/>
           </a:ln>
           <a:effectLst>
             <a:outerShdw sx="100000" sy="100000" kx="0" ky="0" algn="bl" rotWithShape="0" blurRad="76200" dist="25400" dir="5400000">
-              <a:srgbClr val="8B0000">
-                <a:alpha val="12000"/>
+              <a:srgbClr val="1F3864">
+                <a:alpha val="10000"/>
               </a:srgbClr>
             </a:outerShdw>
           </a:effectLst>
@@ -10668,7 +10698,7 @@
             <a:r>
               <a:rPr lang="en-US" sz="3200" b="1" dirty="0">
                 <a:solidFill>
-                  <a:schemeClr val="accent1"/>
+                  <a:schemeClr val="tx2"/>
                 </a:solidFill>
               </a:rPr>
               <a:t>1–2 weeks</a:t>
@@ -10734,14 +10764,14 @@
           </a:solidFill>
           <a:ln w="9525">
             <a:solidFill>
-              <a:schemeClr val="accent4"/>
+              <a:srgbClr val="D5DCE8"/>
             </a:solidFill>
             <a:prstDash val="solid"/>
           </a:ln>
           <a:effectLst>
             <a:outerShdw sx="100000" sy="100000" kx="0" ky="0" algn="bl" rotWithShape="0" blurRad="76200" dist="25400" dir="5400000">
-              <a:srgbClr val="8B0000">
-                <a:alpha val="12000"/>
+              <a:srgbClr val="1F3864">
+                <a:alpha val="10000"/>
               </a:srgbClr>
             </a:outerShdw>
           </a:effectLst>
@@ -10774,7 +10804,7 @@
             <a:r>
               <a:rPr lang="en-US" sz="3200" b="1" dirty="0">
                 <a:solidFill>
-                  <a:schemeClr val="accent1"/>
+                  <a:schemeClr val="tx2"/>
                 </a:solidFill>
               </a:rPr>
               <a:t>≈ 400 000</a:t>
@@ -10986,7 +11016,7 @@
             <a:r>
               <a:rPr lang="en-US" sz="1600" b="1" dirty="0">
                 <a:solidFill>
-                  <a:schemeClr val="accent1"/>
+                  <a:schemeClr val="accent6"/>
                 </a:solidFill>
               </a:rPr>
               <a:t>Limitations</a:t>
@@ -11104,7 +11134,7 @@
             <a:avLst/>
           </a:prstGeom>
           <a:solidFill>
-            <a:schemeClr val="accent1"/>
+            <a:schemeClr val="tx2"/>
           </a:solidFill>
           <a:ln/>
         </p:spPr>
@@ -11166,14 +11196,14 @@
           </a:solidFill>
           <a:ln w="9525">
             <a:solidFill>
-              <a:schemeClr val="accent4"/>
+              <a:srgbClr val="D5DCE8"/>
             </a:solidFill>
             <a:prstDash val="solid"/>
           </a:ln>
           <a:effectLst>
             <a:outerShdw sx="100000" sy="100000" kx="0" ky="0" algn="bl" rotWithShape="0" blurRad="76200" dist="25400" dir="5400000">
-              <a:srgbClr val="8B0000">
-                <a:alpha val="12000"/>
+              <a:srgbClr val="1F3864">
+                <a:alpha val="10000"/>
               </a:srgbClr>
             </a:outerShdw>
           </a:effectLst>
@@ -11329,7 +11359,7 @@
             <a:lvl1pPr>
               <a:defRPr sz="1000">
                 <a:solidFill>
-                  <a:schemeClr val="accent2"/>
+                  <a:schemeClr val="tx2"/>
                 </a:solidFill>
               </a:defRPr>
             </a:lvl1pPr>
@@ -11400,6 +11430,9 @@
                 <a:solidFill>
                   <a:schemeClr val="bg1"/>
                 </a:solidFill>
+                <a:latin typeface="Cambria" pitchFamily="34" charset="0"/>
+                <a:ea typeface="Cambria" pitchFamily="34" charset="-122"/>
+                <a:cs typeface="Cambria" pitchFamily="34" charset="-120"/>
               </a:rPr>
               <a:t>PROPOSED SOLUTION: A HYBRID, HUMAN-IN-THE-LOOP PLATFORM</a:t>
             </a:r>
@@ -11457,7 +11490,7 @@
                   <a:tcPr marL="109728" marR="109728" marT="0" marB="0" anchor="ctr">
                     <a:lnL w="9525" cap="flat" cmpd="sng" algn="ctr">
                       <a:solidFill>
-                        <a:srgbClr val="F0C8C8"/>
+                        <a:srgbClr val="D5DCE8"/>
                       </a:solidFill>
                       <a:prstDash val="solid"/>
                       <a:round/>
@@ -11466,7 +11499,7 @@
                     </a:lnL>
                     <a:lnR w="9525" cap="flat" cmpd="sng" algn="ctr">
                       <a:solidFill>
-                        <a:srgbClr val="F0C8C8"/>
+                        <a:srgbClr val="D5DCE8"/>
                       </a:solidFill>
                       <a:prstDash val="solid"/>
                       <a:round/>
@@ -11475,7 +11508,7 @@
                     </a:lnR>
                     <a:lnT w="9525" cap="flat" cmpd="sng" algn="ctr">
                       <a:solidFill>
-                        <a:srgbClr val="F0C8C8"/>
+                        <a:srgbClr val="D5DCE8"/>
                       </a:solidFill>
                       <a:prstDash val="solid"/>
                       <a:round/>
@@ -11484,7 +11517,7 @@
                     </a:lnT>
                     <a:lnB w="9525" cap="flat" cmpd="sng" algn="ctr">
                       <a:solidFill>
-                        <a:srgbClr val="F0C8C8"/>
+                        <a:srgbClr val="D5DCE8"/>
                       </a:solidFill>
                       <a:prstDash val="solid"/>
                       <a:round/>
@@ -11492,7 +11525,7 @@
                       <a:tailEnd type="none" w="med" len="med"/>
                     </a:lnB>
                     <a:solidFill>
-                      <a:schemeClr val="accent2"/>
+                      <a:schemeClr val="tx2"/>
                     </a:solidFill>
                   </a:tcPr>
                 </a:tc>
@@ -11518,7 +11551,7 @@
                   <a:tcPr marL="109728" marR="109728" marT="0" marB="0" anchor="ctr">
                     <a:lnL w="9525" cap="flat" cmpd="sng" algn="ctr">
                       <a:solidFill>
-                        <a:srgbClr val="F0C8C8"/>
+                        <a:srgbClr val="D5DCE8"/>
                       </a:solidFill>
                       <a:prstDash val="solid"/>
                       <a:round/>
@@ -11527,7 +11560,7 @@
                     </a:lnL>
                     <a:lnR w="9525" cap="flat" cmpd="sng" algn="ctr">
                       <a:solidFill>
-                        <a:srgbClr val="F0C8C8"/>
+                        <a:srgbClr val="D5DCE8"/>
                       </a:solidFill>
                       <a:prstDash val="solid"/>
                       <a:round/>
@@ -11536,7 +11569,7 @@
                     </a:lnR>
                     <a:lnT w="9525" cap="flat" cmpd="sng" algn="ctr">
                       <a:solidFill>
-                        <a:srgbClr val="F0C8C8"/>
+                        <a:srgbClr val="D5DCE8"/>
                       </a:solidFill>
                       <a:prstDash val="solid"/>
                       <a:round/>
@@ -11545,7 +11578,7 @@
                     </a:lnT>
                     <a:lnB w="9525" cap="flat" cmpd="sng" algn="ctr">
                       <a:solidFill>
-                        <a:srgbClr val="F0C8C8"/>
+                        <a:srgbClr val="D5DCE8"/>
                       </a:solidFill>
                       <a:prstDash val="solid"/>
                       <a:round/>
@@ -11553,7 +11586,7 @@
                       <a:tailEnd type="none" w="med" len="med"/>
                     </a:lnB>
                     <a:solidFill>
-                      <a:schemeClr val="accent2"/>
+                      <a:schemeClr val="tx2"/>
                     </a:solidFill>
                   </a:tcPr>
                 </a:tc>
@@ -11579,7 +11612,7 @@
                   <a:tcPr marL="109728" marR="109728" marT="0" marB="0" anchor="ctr">
                     <a:lnL w="9525" cap="flat" cmpd="sng" algn="ctr">
                       <a:solidFill>
-                        <a:srgbClr val="F0C8C8"/>
+                        <a:srgbClr val="D5DCE8"/>
                       </a:solidFill>
                       <a:prstDash val="solid"/>
                       <a:round/>
@@ -11588,7 +11621,7 @@
                     </a:lnL>
                     <a:lnR w="9525" cap="flat" cmpd="sng" algn="ctr">
                       <a:solidFill>
-                        <a:srgbClr val="F0C8C8"/>
+                        <a:srgbClr val="D5DCE8"/>
                       </a:solidFill>
                       <a:prstDash val="solid"/>
                       <a:round/>
@@ -11597,7 +11630,7 @@
                     </a:lnR>
                     <a:lnT w="9525" cap="flat" cmpd="sng" algn="ctr">
                       <a:solidFill>
-                        <a:srgbClr val="F0C8C8"/>
+                        <a:srgbClr val="D5DCE8"/>
                       </a:solidFill>
                       <a:prstDash val="solid"/>
                       <a:round/>
@@ -11606,7 +11639,7 @@
                     </a:lnT>
                     <a:lnB w="9525" cap="flat" cmpd="sng" algn="ctr">
                       <a:solidFill>
-                        <a:srgbClr val="F0C8C8"/>
+                        <a:srgbClr val="D5DCE8"/>
                       </a:solidFill>
                       <a:prstDash val="solid"/>
                       <a:round/>
@@ -11614,7 +11647,7 @@
                       <a:tailEnd type="none" w="med" len="med"/>
                     </a:lnB>
                     <a:solidFill>
-                      <a:schemeClr val="accent2"/>
+                      <a:schemeClr val="tx2"/>
                     </a:solidFill>
                   </a:tcPr>
                 </a:tc>
@@ -11642,7 +11675,7 @@
                   <a:tcPr marL="109728" marR="109728" marT="0" marB="0" anchor="ctr">
                     <a:lnL w="9525" cap="flat" cmpd="sng" algn="ctr">
                       <a:solidFill>
-                        <a:srgbClr val="F0C8C8"/>
+                        <a:srgbClr val="D5DCE8"/>
                       </a:solidFill>
                       <a:prstDash val="solid"/>
                       <a:round/>
@@ -11651,7 +11684,7 @@
                     </a:lnL>
                     <a:lnR w="9525" cap="flat" cmpd="sng" algn="ctr">
                       <a:solidFill>
-                        <a:srgbClr val="F0C8C8"/>
+                        <a:srgbClr val="D5DCE8"/>
                       </a:solidFill>
                       <a:prstDash val="solid"/>
                       <a:round/>
@@ -11660,7 +11693,7 @@
                     </a:lnR>
                     <a:lnT w="9525" cap="flat" cmpd="sng" algn="ctr">
                       <a:solidFill>
-                        <a:srgbClr val="F0C8C8"/>
+                        <a:srgbClr val="D5DCE8"/>
                       </a:solidFill>
                       <a:prstDash val="solid"/>
                       <a:round/>
@@ -11669,7 +11702,7 @@
                     </a:lnT>
                     <a:lnB w="9525" cap="flat" cmpd="sng" algn="ctr">
                       <a:solidFill>
-                        <a:srgbClr val="F0C8C8"/>
+                        <a:srgbClr val="D5DCE8"/>
                       </a:solidFill>
                       <a:prstDash val="solid"/>
                       <a:round/>
@@ -11703,7 +11736,7 @@
                   <a:tcPr marL="109728" marR="109728" marT="0" marB="0" anchor="ctr">
                     <a:lnL w="9525" cap="flat" cmpd="sng" algn="ctr">
                       <a:solidFill>
-                        <a:srgbClr val="F0C8C8"/>
+                        <a:srgbClr val="D5DCE8"/>
                       </a:solidFill>
                       <a:prstDash val="solid"/>
                       <a:round/>
@@ -11712,7 +11745,7 @@
                     </a:lnL>
                     <a:lnR w="9525" cap="flat" cmpd="sng" algn="ctr">
                       <a:solidFill>
-                        <a:srgbClr val="F0C8C8"/>
+                        <a:srgbClr val="D5DCE8"/>
                       </a:solidFill>
                       <a:prstDash val="solid"/>
                       <a:round/>
@@ -11721,7 +11754,7 @@
                     </a:lnR>
                     <a:lnT w="9525" cap="flat" cmpd="sng" algn="ctr">
                       <a:solidFill>
-                        <a:srgbClr val="F0C8C8"/>
+                        <a:srgbClr val="D5DCE8"/>
                       </a:solidFill>
                       <a:prstDash val="solid"/>
                       <a:round/>
@@ -11730,7 +11763,7 @@
                     </a:lnT>
                     <a:lnB w="9525" cap="flat" cmpd="sng" algn="ctr">
                       <a:solidFill>
-                        <a:srgbClr val="F0C8C8"/>
+                        <a:srgbClr val="D5DCE8"/>
                       </a:solidFill>
                       <a:prstDash val="solid"/>
                       <a:round/>
@@ -11764,7 +11797,7 @@
                   <a:tcPr marL="109728" marR="109728" marT="0" marB="0" anchor="ctr">
                     <a:lnL w="9525" cap="flat" cmpd="sng" algn="ctr">
                       <a:solidFill>
-                        <a:srgbClr val="F0C8C8"/>
+                        <a:srgbClr val="D5DCE8"/>
                       </a:solidFill>
                       <a:prstDash val="solid"/>
                       <a:round/>
@@ -11773,7 +11806,7 @@
                     </a:lnL>
                     <a:lnR w="9525" cap="flat" cmpd="sng" algn="ctr">
                       <a:solidFill>
-                        <a:srgbClr val="F0C8C8"/>
+                        <a:srgbClr val="D5DCE8"/>
                       </a:solidFill>
                       <a:prstDash val="solid"/>
                       <a:round/>
@@ -11782,7 +11815,7 @@
                     </a:lnR>
                     <a:lnT w="9525" cap="flat" cmpd="sng" algn="ctr">
                       <a:solidFill>
-                        <a:srgbClr val="F0C8C8"/>
+                        <a:srgbClr val="D5DCE8"/>
                       </a:solidFill>
                       <a:prstDash val="solid"/>
                       <a:round/>
@@ -11791,7 +11824,7 @@
                     </a:lnT>
                     <a:lnB w="9525" cap="flat" cmpd="sng" algn="ctr">
                       <a:solidFill>
-                        <a:srgbClr val="F0C8C8"/>
+                        <a:srgbClr val="D5DCE8"/>
                       </a:solidFill>
                       <a:prstDash val="solid"/>
                       <a:round/>
@@ -11827,7 +11860,7 @@
                   <a:tcPr marL="109728" marR="109728" marT="0" marB="0" anchor="ctr">
                     <a:lnL w="9525" cap="flat" cmpd="sng" algn="ctr">
                       <a:solidFill>
-                        <a:srgbClr val="F0C8C8"/>
+                        <a:srgbClr val="D5DCE8"/>
                       </a:solidFill>
                       <a:prstDash val="solid"/>
                       <a:round/>
@@ -11836,7 +11869,7 @@
                     </a:lnL>
                     <a:lnR w="9525" cap="flat" cmpd="sng" algn="ctr">
                       <a:solidFill>
-                        <a:srgbClr val="F0C8C8"/>
+                        <a:srgbClr val="D5DCE8"/>
                       </a:solidFill>
                       <a:prstDash val="solid"/>
                       <a:round/>
@@ -11845,7 +11878,7 @@
                     </a:lnR>
                     <a:lnT w="9525" cap="flat" cmpd="sng" algn="ctr">
                       <a:solidFill>
-                        <a:srgbClr val="F0C8C8"/>
+                        <a:srgbClr val="D5DCE8"/>
                       </a:solidFill>
                       <a:prstDash val="solid"/>
                       <a:round/>
@@ -11854,7 +11887,7 @@
                     </a:lnT>
                     <a:lnB w="9525" cap="flat" cmpd="sng" algn="ctr">
                       <a:solidFill>
-                        <a:srgbClr val="F0C8C8"/>
+                        <a:srgbClr val="D5DCE8"/>
                       </a:solidFill>
                       <a:prstDash val="solid"/>
                       <a:round/>
@@ -11862,7 +11895,7 @@
                       <a:tailEnd type="none" w="med" len="med"/>
                     </a:lnB>
                     <a:solidFill>
-                      <a:schemeClr val="accent5"/>
+                      <a:schemeClr val="bg2"/>
                     </a:solidFill>
                   </a:tcPr>
                 </a:tc>
@@ -11888,7 +11921,7 @@
                   <a:tcPr marL="109728" marR="109728" marT="0" marB="0" anchor="ctr">
                     <a:lnL w="9525" cap="flat" cmpd="sng" algn="ctr">
                       <a:solidFill>
-                        <a:srgbClr val="F0C8C8"/>
+                        <a:srgbClr val="D5DCE8"/>
                       </a:solidFill>
                       <a:prstDash val="solid"/>
                       <a:round/>
@@ -11897,7 +11930,7 @@
                     </a:lnL>
                     <a:lnR w="9525" cap="flat" cmpd="sng" algn="ctr">
                       <a:solidFill>
-                        <a:srgbClr val="F0C8C8"/>
+                        <a:srgbClr val="D5DCE8"/>
                       </a:solidFill>
                       <a:prstDash val="solid"/>
                       <a:round/>
@@ -11906,7 +11939,7 @@
                     </a:lnR>
                     <a:lnT w="9525" cap="flat" cmpd="sng" algn="ctr">
                       <a:solidFill>
-                        <a:srgbClr val="F0C8C8"/>
+                        <a:srgbClr val="D5DCE8"/>
                       </a:solidFill>
                       <a:prstDash val="solid"/>
                       <a:round/>
@@ -11915,7 +11948,7 @@
                     </a:lnT>
                     <a:lnB w="9525" cap="flat" cmpd="sng" algn="ctr">
                       <a:solidFill>
-                        <a:srgbClr val="F0C8C8"/>
+                        <a:srgbClr val="D5DCE8"/>
                       </a:solidFill>
                       <a:prstDash val="solid"/>
                       <a:round/>
@@ -11923,7 +11956,7 @@
                       <a:tailEnd type="none" w="med" len="med"/>
                     </a:lnB>
                     <a:solidFill>
-                      <a:schemeClr val="accent5"/>
+                      <a:schemeClr val="bg2"/>
                     </a:solidFill>
                   </a:tcPr>
                 </a:tc>
@@ -11949,7 +11982,7 @@
                   <a:tcPr marL="109728" marR="109728" marT="0" marB="0" anchor="ctr">
                     <a:lnL w="9525" cap="flat" cmpd="sng" algn="ctr">
                       <a:solidFill>
-                        <a:srgbClr val="F0C8C8"/>
+                        <a:srgbClr val="D5DCE8"/>
                       </a:solidFill>
                       <a:prstDash val="solid"/>
                       <a:round/>
@@ -11958,7 +11991,7 @@
                     </a:lnL>
                     <a:lnR w="9525" cap="flat" cmpd="sng" algn="ctr">
                       <a:solidFill>
-                        <a:srgbClr val="F0C8C8"/>
+                        <a:srgbClr val="D5DCE8"/>
                       </a:solidFill>
                       <a:prstDash val="solid"/>
                       <a:round/>
@@ -11967,7 +12000,7 @@
                     </a:lnR>
                     <a:lnT w="9525" cap="flat" cmpd="sng" algn="ctr">
                       <a:solidFill>
-                        <a:srgbClr val="F0C8C8"/>
+                        <a:srgbClr val="D5DCE8"/>
                       </a:solidFill>
                       <a:prstDash val="solid"/>
                       <a:round/>
@@ -11976,7 +12009,7 @@
                     </a:lnT>
                     <a:lnB w="9525" cap="flat" cmpd="sng" algn="ctr">
                       <a:solidFill>
-                        <a:srgbClr val="F0C8C8"/>
+                        <a:srgbClr val="D5DCE8"/>
                       </a:solidFill>
                       <a:prstDash val="solid"/>
                       <a:round/>
@@ -11984,7 +12017,7 @@
                       <a:tailEnd type="none" w="med" len="med"/>
                     </a:lnB>
                     <a:solidFill>
-                      <a:schemeClr val="accent5"/>
+                      <a:schemeClr val="bg2"/>
                     </a:solidFill>
                   </a:tcPr>
                 </a:tc>
@@ -12012,7 +12045,7 @@
                   <a:tcPr marL="109728" marR="109728" marT="0" marB="0" anchor="ctr">
                     <a:lnL w="9525" cap="flat" cmpd="sng" algn="ctr">
                       <a:solidFill>
-                        <a:srgbClr val="F0C8C8"/>
+                        <a:srgbClr val="D5DCE8"/>
                       </a:solidFill>
                       <a:prstDash val="solid"/>
                       <a:round/>
@@ -12021,7 +12054,7 @@
                     </a:lnL>
                     <a:lnR w="9525" cap="flat" cmpd="sng" algn="ctr">
                       <a:solidFill>
-                        <a:srgbClr val="F0C8C8"/>
+                        <a:srgbClr val="D5DCE8"/>
                       </a:solidFill>
                       <a:prstDash val="solid"/>
                       <a:round/>
@@ -12030,7 +12063,7 @@
                     </a:lnR>
                     <a:lnT w="9525" cap="flat" cmpd="sng" algn="ctr">
                       <a:solidFill>
-                        <a:srgbClr val="F0C8C8"/>
+                        <a:srgbClr val="D5DCE8"/>
                       </a:solidFill>
                       <a:prstDash val="solid"/>
                       <a:round/>
@@ -12039,7 +12072,7 @@
                     </a:lnT>
                     <a:lnB w="9525" cap="flat" cmpd="sng" algn="ctr">
                       <a:solidFill>
-                        <a:srgbClr val="F0C8C8"/>
+                        <a:srgbClr val="D5DCE8"/>
                       </a:solidFill>
                       <a:prstDash val="solid"/>
                       <a:round/>
@@ -12073,7 +12106,7 @@
                   <a:tcPr marL="109728" marR="109728" marT="0" marB="0" anchor="ctr">
                     <a:lnL w="9525" cap="flat" cmpd="sng" algn="ctr">
                       <a:solidFill>
-                        <a:srgbClr val="F0C8C8"/>
+                        <a:srgbClr val="D5DCE8"/>
                       </a:solidFill>
                       <a:prstDash val="solid"/>
                       <a:round/>
@@ -12082,7 +12115,7 @@
                     </a:lnL>
                     <a:lnR w="9525" cap="flat" cmpd="sng" algn="ctr">
                       <a:solidFill>
-                        <a:srgbClr val="F0C8C8"/>
+                        <a:srgbClr val="D5DCE8"/>
                       </a:solidFill>
                       <a:prstDash val="solid"/>
                       <a:round/>
@@ -12091,7 +12124,7 @@
                     </a:lnR>
                     <a:lnT w="9525" cap="flat" cmpd="sng" algn="ctr">
                       <a:solidFill>
-                        <a:srgbClr val="F0C8C8"/>
+                        <a:srgbClr val="D5DCE8"/>
                       </a:solidFill>
                       <a:prstDash val="solid"/>
                       <a:round/>
@@ -12100,7 +12133,7 @@
                     </a:lnT>
                     <a:lnB w="9525" cap="flat" cmpd="sng" algn="ctr">
                       <a:solidFill>
-                        <a:srgbClr val="F0C8C8"/>
+                        <a:srgbClr val="D5DCE8"/>
                       </a:solidFill>
                       <a:prstDash val="solid"/>
                       <a:round/>
@@ -12134,7 +12167,7 @@
                   <a:tcPr marL="109728" marR="109728" marT="0" marB="0" anchor="ctr">
                     <a:lnL w="9525" cap="flat" cmpd="sng" algn="ctr">
                       <a:solidFill>
-                        <a:srgbClr val="F0C8C8"/>
+                        <a:srgbClr val="D5DCE8"/>
                       </a:solidFill>
                       <a:prstDash val="solid"/>
                       <a:round/>
@@ -12143,7 +12176,7 @@
                     </a:lnL>
                     <a:lnR w="9525" cap="flat" cmpd="sng" algn="ctr">
                       <a:solidFill>
-                        <a:srgbClr val="F0C8C8"/>
+                        <a:srgbClr val="D5DCE8"/>
                       </a:solidFill>
                       <a:prstDash val="solid"/>
                       <a:round/>
@@ -12152,7 +12185,7 @@
                     </a:lnR>
                     <a:lnT w="9525" cap="flat" cmpd="sng" algn="ctr">
                       <a:solidFill>
-                        <a:srgbClr val="F0C8C8"/>
+                        <a:srgbClr val="D5DCE8"/>
                       </a:solidFill>
                       <a:prstDash val="solid"/>
                       <a:round/>
@@ -12161,7 +12194,7 @@
                     </a:lnT>
                     <a:lnB w="9525" cap="flat" cmpd="sng" algn="ctr">
                       <a:solidFill>
-                        <a:srgbClr val="F0C8C8"/>
+                        <a:srgbClr val="D5DCE8"/>
                       </a:solidFill>
                       <a:prstDash val="solid"/>
                       <a:round/>
@@ -12197,7 +12230,7 @@
                   <a:tcPr marL="109728" marR="109728" marT="0" marB="0" anchor="ctr">
                     <a:lnL w="9525" cap="flat" cmpd="sng" algn="ctr">
                       <a:solidFill>
-                        <a:srgbClr val="F0C8C8"/>
+                        <a:srgbClr val="D5DCE8"/>
                       </a:solidFill>
                       <a:prstDash val="solid"/>
                       <a:round/>
@@ -12206,7 +12239,7 @@
                     </a:lnL>
                     <a:lnR w="9525" cap="flat" cmpd="sng" algn="ctr">
                       <a:solidFill>
-                        <a:srgbClr val="F0C8C8"/>
+                        <a:srgbClr val="D5DCE8"/>
                       </a:solidFill>
                       <a:prstDash val="solid"/>
                       <a:round/>
@@ -12215,7 +12248,7 @@
                     </a:lnR>
                     <a:lnT w="9525" cap="flat" cmpd="sng" algn="ctr">
                       <a:solidFill>
-                        <a:srgbClr val="F0C8C8"/>
+                        <a:srgbClr val="D5DCE8"/>
                       </a:solidFill>
                       <a:prstDash val="solid"/>
                       <a:round/>
@@ -12224,7 +12257,7 @@
                     </a:lnT>
                     <a:lnB w="9525" cap="flat" cmpd="sng" algn="ctr">
                       <a:solidFill>
-                        <a:srgbClr val="F0C8C8"/>
+                        <a:srgbClr val="D5DCE8"/>
                       </a:solidFill>
                       <a:prstDash val="solid"/>
                       <a:round/>
@@ -12232,7 +12265,7 @@
                       <a:tailEnd type="none" w="med" len="med"/>
                     </a:lnB>
                     <a:solidFill>
-                      <a:schemeClr val="accent5"/>
+                      <a:schemeClr val="bg2"/>
                     </a:solidFill>
                   </a:tcPr>
                 </a:tc>
@@ -12258,7 +12291,7 @@
                   <a:tcPr marL="109728" marR="109728" marT="0" marB="0" anchor="ctr">
                     <a:lnL w="9525" cap="flat" cmpd="sng" algn="ctr">
                       <a:solidFill>
-                        <a:srgbClr val="F0C8C8"/>
+                        <a:srgbClr val="D5DCE8"/>
                       </a:solidFill>
                       <a:prstDash val="solid"/>
                       <a:round/>
@@ -12267,7 +12300,7 @@
                     </a:lnL>
                     <a:lnR w="9525" cap="flat" cmpd="sng" algn="ctr">
                       <a:solidFill>
-                        <a:srgbClr val="F0C8C8"/>
+                        <a:srgbClr val="D5DCE8"/>
                       </a:solidFill>
                       <a:prstDash val="solid"/>
                       <a:round/>
@@ -12276,7 +12309,7 @@
                     </a:lnR>
                     <a:lnT w="9525" cap="flat" cmpd="sng" algn="ctr">
                       <a:solidFill>
-                        <a:srgbClr val="F0C8C8"/>
+                        <a:srgbClr val="D5DCE8"/>
                       </a:solidFill>
                       <a:prstDash val="solid"/>
                       <a:round/>
@@ -12285,7 +12318,7 @@
                     </a:lnT>
                     <a:lnB w="9525" cap="flat" cmpd="sng" algn="ctr">
                       <a:solidFill>
-                        <a:srgbClr val="F0C8C8"/>
+                        <a:srgbClr val="D5DCE8"/>
                       </a:solidFill>
                       <a:prstDash val="solid"/>
                       <a:round/>
@@ -12293,7 +12326,7 @@
                       <a:tailEnd type="none" w="med" len="med"/>
                     </a:lnB>
                     <a:solidFill>
-                      <a:schemeClr val="accent5"/>
+                      <a:schemeClr val="bg2"/>
                     </a:solidFill>
                   </a:tcPr>
                 </a:tc>
@@ -12319,7 +12352,7 @@
                   <a:tcPr marL="109728" marR="109728" marT="0" marB="0" anchor="ctr">
                     <a:lnL w="9525" cap="flat" cmpd="sng" algn="ctr">
                       <a:solidFill>
-                        <a:srgbClr val="F0C8C8"/>
+                        <a:srgbClr val="D5DCE8"/>
                       </a:solidFill>
                       <a:prstDash val="solid"/>
                       <a:round/>
@@ -12328,7 +12361,7 @@
                     </a:lnL>
                     <a:lnR w="9525" cap="flat" cmpd="sng" algn="ctr">
                       <a:solidFill>
-                        <a:srgbClr val="F0C8C8"/>
+                        <a:srgbClr val="D5DCE8"/>
                       </a:solidFill>
                       <a:prstDash val="solid"/>
                       <a:round/>
@@ -12337,7 +12370,7 @@
                     </a:lnR>
                     <a:lnT w="9525" cap="flat" cmpd="sng" algn="ctr">
                       <a:solidFill>
-                        <a:srgbClr val="F0C8C8"/>
+                        <a:srgbClr val="D5DCE8"/>
                       </a:solidFill>
                       <a:prstDash val="solid"/>
                       <a:round/>
@@ -12346,7 +12379,7 @@
                     </a:lnT>
                     <a:lnB w="9525" cap="flat" cmpd="sng" algn="ctr">
                       <a:solidFill>
-                        <a:srgbClr val="F0C8C8"/>
+                        <a:srgbClr val="D5DCE8"/>
                       </a:solidFill>
                       <a:prstDash val="solid"/>
                       <a:round/>
@@ -12354,7 +12387,7 @@
                       <a:tailEnd type="none" w="med" len="med"/>
                     </a:lnB>
                     <a:solidFill>
-                      <a:schemeClr val="accent5"/>
+                      <a:schemeClr val="bg2"/>
                     </a:solidFill>
                   </a:tcPr>
                 </a:tc>
@@ -12382,7 +12415,7 @@
                   <a:tcPr marL="109728" marR="109728" marT="0" marB="0" anchor="ctr">
                     <a:lnL w="9525" cap="flat" cmpd="sng" algn="ctr">
                       <a:solidFill>
-                        <a:srgbClr val="F0C8C8"/>
+                        <a:srgbClr val="D5DCE8"/>
                       </a:solidFill>
                       <a:prstDash val="solid"/>
                       <a:round/>
@@ -12391,7 +12424,7 @@
                     </a:lnL>
                     <a:lnR w="9525" cap="flat" cmpd="sng" algn="ctr">
                       <a:solidFill>
-                        <a:srgbClr val="F0C8C8"/>
+                        <a:srgbClr val="D5DCE8"/>
                       </a:solidFill>
                       <a:prstDash val="solid"/>
                       <a:round/>
@@ -12400,7 +12433,7 @@
                     </a:lnR>
                     <a:lnT w="9525" cap="flat" cmpd="sng" algn="ctr">
                       <a:solidFill>
-                        <a:srgbClr val="F0C8C8"/>
+                        <a:srgbClr val="D5DCE8"/>
                       </a:solidFill>
                       <a:prstDash val="solid"/>
                       <a:round/>
@@ -12409,7 +12442,7 @@
                     </a:lnT>
                     <a:lnB w="9525" cap="flat" cmpd="sng" algn="ctr">
                       <a:solidFill>
-                        <a:srgbClr val="F0C8C8"/>
+                        <a:srgbClr val="D5DCE8"/>
                       </a:solidFill>
                       <a:prstDash val="solid"/>
                       <a:round/>
@@ -12417,7 +12450,7 @@
                       <a:tailEnd type="none" w="med" len="med"/>
                     </a:lnB>
                     <a:solidFill>
-                      <a:schemeClr val="accent1"/>
+                      <a:schemeClr val="accent2"/>
                     </a:solidFill>
                   </a:tcPr>
                 </a:tc>
@@ -12443,7 +12476,7 @@
                   <a:tcPr marL="109728" marR="109728" marT="0" marB="0" anchor="ctr">
                     <a:lnL w="9525" cap="flat" cmpd="sng" algn="ctr">
                       <a:solidFill>
-                        <a:srgbClr val="F0C8C8"/>
+                        <a:srgbClr val="D5DCE8"/>
                       </a:solidFill>
                       <a:prstDash val="solid"/>
                       <a:round/>
@@ -12452,7 +12485,7 @@
                     </a:lnL>
                     <a:lnR w="9525" cap="flat" cmpd="sng" algn="ctr">
                       <a:solidFill>
-                        <a:srgbClr val="F0C8C8"/>
+                        <a:srgbClr val="D5DCE8"/>
                       </a:solidFill>
                       <a:prstDash val="solid"/>
                       <a:round/>
@@ -12461,7 +12494,7 @@
                     </a:lnR>
                     <a:lnT w="9525" cap="flat" cmpd="sng" algn="ctr">
                       <a:solidFill>
-                        <a:srgbClr val="F0C8C8"/>
+                        <a:srgbClr val="D5DCE8"/>
                       </a:solidFill>
                       <a:prstDash val="solid"/>
                       <a:round/>
@@ -12470,7 +12503,7 @@
                     </a:lnT>
                     <a:lnB w="9525" cap="flat" cmpd="sng" algn="ctr">
                       <a:solidFill>
-                        <a:srgbClr val="F0C8C8"/>
+                        <a:srgbClr val="D5DCE8"/>
                       </a:solidFill>
                       <a:prstDash val="solid"/>
                       <a:round/>
@@ -12478,7 +12511,7 @@
                       <a:tailEnd type="none" w="med" len="med"/>
                     </a:lnB>
                     <a:solidFill>
-                      <a:schemeClr val="accent1"/>
+                      <a:schemeClr val="accent2"/>
                     </a:solidFill>
                   </a:tcPr>
                 </a:tc>
@@ -12504,7 +12537,7 @@
                   <a:tcPr marL="109728" marR="109728" marT="0" marB="0" anchor="ctr">
                     <a:lnL w="9525" cap="flat" cmpd="sng" algn="ctr">
                       <a:solidFill>
-                        <a:srgbClr val="F0C8C8"/>
+                        <a:srgbClr val="D5DCE8"/>
                       </a:solidFill>
                       <a:prstDash val="solid"/>
                       <a:round/>
@@ -12513,7 +12546,7 @@
                     </a:lnL>
                     <a:lnR w="9525" cap="flat" cmpd="sng" algn="ctr">
                       <a:solidFill>
-                        <a:srgbClr val="F0C8C8"/>
+                        <a:srgbClr val="D5DCE8"/>
                       </a:solidFill>
                       <a:prstDash val="solid"/>
                       <a:round/>
@@ -12522,7 +12555,7 @@
                     </a:lnR>
                     <a:lnT w="9525" cap="flat" cmpd="sng" algn="ctr">
                       <a:solidFill>
-                        <a:srgbClr val="F0C8C8"/>
+                        <a:srgbClr val="D5DCE8"/>
                       </a:solidFill>
                       <a:prstDash val="solid"/>
                       <a:round/>
@@ -12531,7 +12564,7 @@
                     </a:lnT>
                     <a:lnB w="9525" cap="flat" cmpd="sng" algn="ctr">
                       <a:solidFill>
-                        <a:srgbClr val="F0C8C8"/>
+                        <a:srgbClr val="D5DCE8"/>
                       </a:solidFill>
                       <a:prstDash val="solid"/>
                       <a:round/>
@@ -12539,7 +12572,7 @@
                       <a:tailEnd type="none" w="med" len="med"/>
                     </a:lnB>
                     <a:solidFill>
-                      <a:schemeClr val="accent1"/>
+                      <a:schemeClr val="accent2"/>
                     </a:solidFill>
                   </a:tcPr>
                 </a:tc>
@@ -12569,14 +12602,14 @@
           </a:solidFill>
           <a:ln w="9525">
             <a:solidFill>
-              <a:schemeClr val="accent4"/>
+              <a:srgbClr val="D5DCE8"/>
             </a:solidFill>
             <a:prstDash val="solid"/>
           </a:ln>
           <a:effectLst>
             <a:outerShdw sx="100000" sy="100000" kx="0" ky="0" algn="bl" rotWithShape="0" blurRad="76200" dist="25400" dir="5400000">
-              <a:srgbClr val="8B0000">
-                <a:alpha val="12000"/>
+              <a:srgbClr val="1F3864">
+                <a:alpha val="10000"/>
               </a:srgbClr>
             </a:outerShdw>
           </a:effectLst>
@@ -12597,7 +12630,7 @@
             <a:avLst/>
           </a:prstGeom>
           <a:solidFill>
-            <a:schemeClr val="accent1"/>
+            <a:schemeClr val="tx2"/>
           </a:solidFill>
           <a:ln/>
         </p:spPr>
@@ -12653,7 +12686,7 @@
             <a:r>
               <a:rPr lang="en-US" sz="1600" b="1" dirty="0">
                 <a:solidFill>
-                  <a:schemeClr val="accent2"/>
+                  <a:schemeClr val="tx2"/>
                 </a:solidFill>
               </a:rPr>
               <a:t>AI proposes</a:t>
@@ -12697,14 +12730,14 @@
           </a:solidFill>
           <a:ln w="9525">
             <a:solidFill>
-              <a:schemeClr val="accent4"/>
+              <a:srgbClr val="D5DCE8"/>
             </a:solidFill>
             <a:prstDash val="solid"/>
           </a:ln>
           <a:effectLst>
             <a:outerShdw sx="100000" sy="100000" kx="0" ky="0" algn="bl" rotWithShape="0" blurRad="76200" dist="25400" dir="5400000">
-              <a:srgbClr val="8B0000">
-                <a:alpha val="12000"/>
+              <a:srgbClr val="1F3864">
+                <a:alpha val="10000"/>
               </a:srgbClr>
             </a:outerShdw>
           </a:effectLst>
@@ -12725,7 +12758,7 @@
             <a:avLst/>
           </a:prstGeom>
           <a:solidFill>
-            <a:schemeClr val="accent1"/>
+            <a:schemeClr val="tx2"/>
           </a:solidFill>
           <a:ln/>
         </p:spPr>
@@ -12781,7 +12814,7 @@
             <a:r>
               <a:rPr lang="en-US" sz="1600" b="1" dirty="0">
                 <a:solidFill>
-                  <a:schemeClr val="accent2"/>
+                  <a:schemeClr val="tx2"/>
                 </a:solidFill>
               </a:rPr>
               <a:t>Teacher decides</a:t>
@@ -12825,14 +12858,14 @@
           </a:solidFill>
           <a:ln w="9525">
             <a:solidFill>
-              <a:schemeClr val="accent4"/>
+              <a:srgbClr val="D5DCE8"/>
             </a:solidFill>
             <a:prstDash val="solid"/>
           </a:ln>
           <a:effectLst>
             <a:outerShdw sx="100000" sy="100000" kx="0" ky="0" algn="bl" rotWithShape="0" blurRad="76200" dist="25400" dir="5400000">
-              <a:srgbClr val="8B0000">
-                <a:alpha val="12000"/>
+              <a:srgbClr val="1F3864">
+                <a:alpha val="10000"/>
               </a:srgbClr>
             </a:outerShdw>
           </a:effectLst>
@@ -12853,7 +12886,7 @@
             <a:avLst/>
           </a:prstGeom>
           <a:solidFill>
-            <a:schemeClr val="accent1"/>
+            <a:schemeClr val="tx2"/>
           </a:solidFill>
           <a:ln/>
         </p:spPr>
@@ -12909,7 +12942,7 @@
             <a:r>
               <a:rPr lang="en-US" sz="1600" b="1" dirty="0">
                 <a:solidFill>
-                  <a:schemeClr val="accent2"/>
+                  <a:schemeClr val="tx2"/>
                 </a:solidFill>
               </a:rPr>
               <a:t>Reliability measured</a:t>
@@ -12962,7 +12995,7 @@
             <a:lvl1pPr>
               <a:defRPr sz="1000">
                 <a:solidFill>
-                  <a:schemeClr val="accent2"/>
+                  <a:schemeClr val="tx2"/>
                 </a:solidFill>
               </a:defRPr>
             </a:lvl1pPr>
@@ -13033,6 +13066,9 @@
                 <a:solidFill>
                   <a:schemeClr val="bg1"/>
                 </a:solidFill>
+                <a:latin typeface="Cambria" pitchFamily="34" charset="0"/>
+                <a:ea typeface="Cambria" pitchFamily="34" charset="-122"/>
+                <a:cs typeface="Cambria" pitchFamily="34" charset="-120"/>
               </a:rPr>
               <a:t>METHODOLOGY USED: ITERATIVE &amp; INCREMENTAL (AGILE SCRUM)</a:t>
             </a:r>
@@ -13055,7 +13091,7 @@
             <a:avLst/>
           </a:prstGeom>
           <a:solidFill>
-            <a:schemeClr val="accent3"/>
+            <a:schemeClr val="tx2"/>
           </a:solidFill>
           <a:ln/>
         </p:spPr>
@@ -13141,6 +13177,190 @@
         <p:spPr>
           <a:xfrm>
             <a:off x="2404872" y="1234440"/>
+            <a:ext cx="1920240" cy="731520"/>
+          </a:xfrm>
+          <a:prstGeom prst="chevron">
+            <a:avLst/>
+          </a:prstGeom>
+          <a:solidFill>
+            <a:schemeClr val="tx2"/>
+          </a:solidFill>
+          <a:ln/>
+        </p:spPr>
+      </p:sp>
+      <p:sp>
+        <p:nvSpPr>
+          <p:cNvPr id="7" name="Text 5"/>
+          <p:cNvSpPr txBox="1"/>
+          <p:nvPr/>
+        </p:nvSpPr>
+        <p:spPr>
+          <a:xfrm>
+            <a:off x="2679192" y="1234440"/>
+            <a:ext cx="1371600" cy="731520"/>
+          </a:xfrm>
+          <a:prstGeom prst="rect">
+            <a:avLst/>
+          </a:prstGeom>
+          <a:noFill/>
+          <a:ln/>
+        </p:spPr>
+        <p:txBody>
+          <a:bodyPr wrap="square" lIns="0" tIns="0" rIns="0" bIns="0" rtlCol="0" anchor="ctr"/>
+          <a:lstStyle/>
+          <a:p>
+            <a:pPr algn="ctr" indent="0" marL="0">
+              <a:buNone/>
+            </a:pPr>
+            <a:r>
+              <a:rPr lang="en-US" sz="1500" b="1" dirty="0">
+                <a:solidFill>
+                  <a:schemeClr val="bg1"/>
+                </a:solidFill>
+              </a:rPr>
+              <a:t>Sprint 2</a:t>
+            </a:r>
+            <a:endParaRPr lang="en-US" sz="1500" dirty="0"/>
+          </a:p>
+        </p:txBody>
+      </p:sp>
+      <p:sp>
+        <p:nvSpPr>
+          <p:cNvPr id="8" name="Text 6"/>
+          <p:cNvSpPr txBox="1"/>
+          <p:nvPr/>
+        </p:nvSpPr>
+        <p:spPr>
+          <a:xfrm>
+            <a:off x="2450592" y="2057400"/>
+            <a:ext cx="1783080" cy="594360"/>
+          </a:xfrm>
+          <a:prstGeom prst="rect">
+            <a:avLst/>
+          </a:prstGeom>
+          <a:noFill/>
+          <a:ln/>
+        </p:spPr>
+        <p:txBody>
+          <a:bodyPr wrap="square" lIns="0" tIns="0" rIns="0" bIns="0" rtlCol="0" anchor="t"/>
+          <a:lstStyle/>
+          <a:p>
+            <a:pPr algn="ctr" indent="0" marL="0">
+              <a:buNone/>
+            </a:pPr>
+            <a:r>
+              <a:rPr lang="en-US" sz="1300" dirty="0">
+                <a:solidFill>
+                  <a:schemeClr val="tx1"/>
+                </a:solidFill>
+              </a:rPr>
+              <a:t>Login, courses, exams</a:t>
+            </a:r>
+            <a:endParaRPr lang="en-US" sz="1300" dirty="0"/>
+          </a:p>
+        </p:txBody>
+      </p:sp>
+      <p:sp>
+        <p:nvSpPr>
+          <p:cNvPr id="9" name="Sprint 3"/>
+          <p:cNvSpPr/>
+          <p:nvPr/>
+        </p:nvSpPr>
+        <p:spPr>
+          <a:xfrm>
+            <a:off x="4261104" y="1234440"/>
+            <a:ext cx="1920240" cy="731520"/>
+          </a:xfrm>
+          <a:prstGeom prst="chevron">
+            <a:avLst/>
+          </a:prstGeom>
+          <a:solidFill>
+            <a:schemeClr val="tx2"/>
+          </a:solidFill>
+          <a:ln/>
+        </p:spPr>
+      </p:sp>
+      <p:sp>
+        <p:nvSpPr>
+          <p:cNvPr id="10" name="Text 8"/>
+          <p:cNvSpPr txBox="1"/>
+          <p:nvPr/>
+        </p:nvSpPr>
+        <p:spPr>
+          <a:xfrm>
+            <a:off x="4535424" y="1234440"/>
+            <a:ext cx="1371600" cy="731520"/>
+          </a:xfrm>
+          <a:prstGeom prst="rect">
+            <a:avLst/>
+          </a:prstGeom>
+          <a:noFill/>
+          <a:ln/>
+        </p:spPr>
+        <p:txBody>
+          <a:bodyPr wrap="square" lIns="0" tIns="0" rIns="0" bIns="0" rtlCol="0" anchor="ctr"/>
+          <a:lstStyle/>
+          <a:p>
+            <a:pPr algn="ctr" indent="0" marL="0">
+              <a:buNone/>
+            </a:pPr>
+            <a:r>
+              <a:rPr lang="en-US" sz="1500" b="1" dirty="0">
+                <a:solidFill>
+                  <a:schemeClr val="bg1"/>
+                </a:solidFill>
+              </a:rPr>
+              <a:t>Sprint 3</a:t>
+            </a:r>
+            <a:endParaRPr lang="en-US" sz="1500" dirty="0"/>
+          </a:p>
+        </p:txBody>
+      </p:sp>
+      <p:sp>
+        <p:nvSpPr>
+          <p:cNvPr id="11" name="Text 9"/>
+          <p:cNvSpPr txBox="1"/>
+          <p:nvPr/>
+        </p:nvSpPr>
+        <p:spPr>
+          <a:xfrm>
+            <a:off x="4306824" y="2057400"/>
+            <a:ext cx="1783080" cy="594360"/>
+          </a:xfrm>
+          <a:prstGeom prst="rect">
+            <a:avLst/>
+          </a:prstGeom>
+          <a:noFill/>
+          <a:ln/>
+        </p:spPr>
+        <p:txBody>
+          <a:bodyPr wrap="square" lIns="0" tIns="0" rIns="0" bIns="0" rtlCol="0" anchor="t"/>
+          <a:lstStyle/>
+          <a:p>
+            <a:pPr algn="ctr" indent="0" marL="0">
+              <a:buNone/>
+            </a:pPr>
+            <a:r>
+              <a:rPr lang="en-US" sz="1300" dirty="0">
+                <a:solidFill>
+                  <a:schemeClr val="tx1"/>
+                </a:solidFill>
+              </a:rPr>
+              <a:t>Exam room and timer</a:t>
+            </a:r>
+            <a:endParaRPr lang="en-US" sz="1300" dirty="0"/>
+          </a:p>
+        </p:txBody>
+      </p:sp>
+      <p:sp>
+        <p:nvSpPr>
+          <p:cNvPr id="12" name="Sprint 4"/>
+          <p:cNvSpPr/>
+          <p:nvPr/>
+        </p:nvSpPr>
+        <p:spPr>
+          <a:xfrm>
+            <a:off x="6117336" y="1234440"/>
             <a:ext cx="1920240" cy="731520"/>
           </a:xfrm>
           <a:prstGeom prst="chevron">
@@ -13154,190 +13374,6 @@
       </p:sp>
       <p:sp>
         <p:nvSpPr>
-          <p:cNvPr id="7" name="Text 5"/>
-          <p:cNvSpPr txBox="1"/>
-          <p:nvPr/>
-        </p:nvSpPr>
-        <p:spPr>
-          <a:xfrm>
-            <a:off x="2679192" y="1234440"/>
-            <a:ext cx="1371600" cy="731520"/>
-          </a:xfrm>
-          <a:prstGeom prst="rect">
-            <a:avLst/>
-          </a:prstGeom>
-          <a:noFill/>
-          <a:ln/>
-        </p:spPr>
-        <p:txBody>
-          <a:bodyPr wrap="square" lIns="0" tIns="0" rIns="0" bIns="0" rtlCol="0" anchor="ctr"/>
-          <a:lstStyle/>
-          <a:p>
-            <a:pPr algn="ctr" indent="0" marL="0">
-              <a:buNone/>
-            </a:pPr>
-            <a:r>
-              <a:rPr lang="en-US" sz="1500" b="1" dirty="0">
-                <a:solidFill>
-                  <a:schemeClr val="bg1"/>
-                </a:solidFill>
-              </a:rPr>
-              <a:t>Sprint 2</a:t>
-            </a:r>
-            <a:endParaRPr lang="en-US" sz="1500" dirty="0"/>
-          </a:p>
-        </p:txBody>
-      </p:sp>
-      <p:sp>
-        <p:nvSpPr>
-          <p:cNvPr id="8" name="Text 6"/>
-          <p:cNvSpPr txBox="1"/>
-          <p:nvPr/>
-        </p:nvSpPr>
-        <p:spPr>
-          <a:xfrm>
-            <a:off x="2450592" y="2057400"/>
-            <a:ext cx="1783080" cy="594360"/>
-          </a:xfrm>
-          <a:prstGeom prst="rect">
-            <a:avLst/>
-          </a:prstGeom>
-          <a:noFill/>
-          <a:ln/>
-        </p:spPr>
-        <p:txBody>
-          <a:bodyPr wrap="square" lIns="0" tIns="0" rIns="0" bIns="0" rtlCol="0" anchor="t"/>
-          <a:lstStyle/>
-          <a:p>
-            <a:pPr algn="ctr" indent="0" marL="0">
-              <a:buNone/>
-            </a:pPr>
-            <a:r>
-              <a:rPr lang="en-US" sz="1300" dirty="0">
-                <a:solidFill>
-                  <a:schemeClr val="tx1"/>
-                </a:solidFill>
-              </a:rPr>
-              <a:t>Login, courses, exams</a:t>
-            </a:r>
-            <a:endParaRPr lang="en-US" sz="1300" dirty="0"/>
-          </a:p>
-        </p:txBody>
-      </p:sp>
-      <p:sp>
-        <p:nvSpPr>
-          <p:cNvPr id="9" name="Sprint 3"/>
-          <p:cNvSpPr/>
-          <p:nvPr/>
-        </p:nvSpPr>
-        <p:spPr>
-          <a:xfrm>
-            <a:off x="4261104" y="1234440"/>
-            <a:ext cx="1920240" cy="731520"/>
-          </a:xfrm>
-          <a:prstGeom prst="chevron">
-            <a:avLst/>
-          </a:prstGeom>
-          <a:solidFill>
-            <a:schemeClr val="accent1"/>
-          </a:solidFill>
-          <a:ln/>
-        </p:spPr>
-      </p:sp>
-      <p:sp>
-        <p:nvSpPr>
-          <p:cNvPr id="10" name="Text 8"/>
-          <p:cNvSpPr txBox="1"/>
-          <p:nvPr/>
-        </p:nvSpPr>
-        <p:spPr>
-          <a:xfrm>
-            <a:off x="4535424" y="1234440"/>
-            <a:ext cx="1371600" cy="731520"/>
-          </a:xfrm>
-          <a:prstGeom prst="rect">
-            <a:avLst/>
-          </a:prstGeom>
-          <a:noFill/>
-          <a:ln/>
-        </p:spPr>
-        <p:txBody>
-          <a:bodyPr wrap="square" lIns="0" tIns="0" rIns="0" bIns="0" rtlCol="0" anchor="ctr"/>
-          <a:lstStyle/>
-          <a:p>
-            <a:pPr algn="ctr" indent="0" marL="0">
-              <a:buNone/>
-            </a:pPr>
-            <a:r>
-              <a:rPr lang="en-US" sz="1500" b="1" dirty="0">
-                <a:solidFill>
-                  <a:schemeClr val="bg1"/>
-                </a:solidFill>
-              </a:rPr>
-              <a:t>Sprint 3</a:t>
-            </a:r>
-            <a:endParaRPr lang="en-US" sz="1500" dirty="0"/>
-          </a:p>
-        </p:txBody>
-      </p:sp>
-      <p:sp>
-        <p:nvSpPr>
-          <p:cNvPr id="11" name="Text 9"/>
-          <p:cNvSpPr txBox="1"/>
-          <p:nvPr/>
-        </p:nvSpPr>
-        <p:spPr>
-          <a:xfrm>
-            <a:off x="4306824" y="2057400"/>
-            <a:ext cx="1783080" cy="594360"/>
-          </a:xfrm>
-          <a:prstGeom prst="rect">
-            <a:avLst/>
-          </a:prstGeom>
-          <a:noFill/>
-          <a:ln/>
-        </p:spPr>
-        <p:txBody>
-          <a:bodyPr wrap="square" lIns="0" tIns="0" rIns="0" bIns="0" rtlCol="0" anchor="t"/>
-          <a:lstStyle/>
-          <a:p>
-            <a:pPr algn="ctr" indent="0" marL="0">
-              <a:buNone/>
-            </a:pPr>
-            <a:r>
-              <a:rPr lang="en-US" sz="1300" dirty="0">
-                <a:solidFill>
-                  <a:schemeClr val="tx1"/>
-                </a:solidFill>
-              </a:rPr>
-              <a:t>Exam room and timer</a:t>
-            </a:r>
-            <a:endParaRPr lang="en-US" sz="1300" dirty="0"/>
-          </a:p>
-        </p:txBody>
-      </p:sp>
-      <p:sp>
-        <p:nvSpPr>
-          <p:cNvPr id="12" name="Sprint 4"/>
-          <p:cNvSpPr/>
-          <p:nvPr/>
-        </p:nvSpPr>
-        <p:spPr>
-          <a:xfrm>
-            <a:off x="6117336" y="1234440"/>
-            <a:ext cx="1920240" cy="731520"/>
-          </a:xfrm>
-          <a:prstGeom prst="chevron">
-            <a:avLst/>
-          </a:prstGeom>
-          <a:solidFill>
-            <a:schemeClr val="accent3"/>
-          </a:solidFill>
-          <a:ln/>
-        </p:spPr>
-      </p:sp>
-      <p:sp>
-        <p:nvSpPr>
           <p:cNvPr id="13" name="Text 11"/>
           <p:cNvSpPr txBox="1"/>
           <p:nvPr/>
@@ -13423,7 +13459,7 @@
             <a:avLst/>
           </a:prstGeom>
           <a:solidFill>
-            <a:schemeClr val="accent2"/>
+            <a:schemeClr val="tx2"/>
           </a:solidFill>
           <a:ln/>
         </p:spPr>
@@ -13515,7 +13551,7 @@
             <a:avLst/>
           </a:prstGeom>
           <a:solidFill>
-            <a:schemeClr val="accent1"/>
+            <a:schemeClr val="tx2"/>
           </a:solidFill>
           <a:ln/>
         </p:spPr>
@@ -13609,18 +13645,18 @@
             </a:avLst>
           </a:prstGeom>
           <a:solidFill>
-            <a:schemeClr val="accent5"/>
+            <a:schemeClr val="bg2"/>
           </a:solidFill>
           <a:ln w="9525">
             <a:solidFill>
-              <a:schemeClr val="accent4"/>
+              <a:srgbClr val="D5DCE8"/>
             </a:solidFill>
             <a:prstDash val="solid"/>
           </a:ln>
           <a:effectLst>
             <a:outerShdw sx="100000" sy="100000" kx="0" ky="0" algn="bl" rotWithShape="0" blurRad="76200" dist="25400" dir="5400000">
-              <a:srgbClr val="8B0000">
-                <a:alpha val="12000"/>
+              <a:srgbClr val="1F3864">
+                <a:alpha val="10000"/>
               </a:srgbClr>
             </a:outerShdw>
           </a:effectLst>
@@ -13653,7 +13689,7 @@
             <a:r>
               <a:rPr lang="en-US" sz="1500" i="1" dirty="0">
                 <a:solidFill>
-                  <a:schemeClr val="accent2"/>
+                  <a:schemeClr val="tx2"/>
                 </a:solidFill>
               </a:rPr>
               <a:t>Each sprint repeats the same cycle and delivers a working, tested part of the platform</a:t>
@@ -13677,7 +13713,7 @@
             <a:avLst/>
           </a:prstGeom>
           <a:solidFill>
-            <a:schemeClr val="accent1"/>
+            <a:schemeClr val="tx2"/>
           </a:solidFill>
           <a:ln/>
         </p:spPr>
@@ -13757,7 +13793,7 @@
             <a:avLst/>
           </a:prstGeom>
           <a:solidFill>
-            <a:schemeClr val="accent1"/>
+            <a:schemeClr val="tx2"/>
           </a:solidFill>
           <a:ln/>
         </p:spPr>
@@ -13837,7 +13873,7 @@
             <a:avLst/>
           </a:prstGeom>
           <a:solidFill>
-            <a:schemeClr val="accent1"/>
+            <a:schemeClr val="tx2"/>
           </a:solidFill>
           <a:ln/>
         </p:spPr>
@@ -13917,7 +13953,7 @@
             <a:avLst/>
           </a:prstGeom>
           <a:solidFill>
-            <a:schemeClr val="accent1"/>
+            <a:schemeClr val="tx2"/>
           </a:solidFill>
           <a:ln/>
         </p:spPr>
@@ -13997,7 +14033,7 @@
             <a:avLst/>
           </a:prstGeom>
           <a:solidFill>
-            <a:schemeClr val="accent1"/>
+            <a:schemeClr val="tx2"/>
           </a:solidFill>
           <a:ln/>
         </p:spPr>
@@ -14077,7 +14113,7 @@
             <a:avLst/>
           </a:prstGeom>
           <a:solidFill>
-            <a:schemeClr val="accent2"/>
+            <a:schemeClr val="tx2"/>
           </a:solidFill>
           <a:ln/>
         </p:spPr>
@@ -14169,7 +14205,7 @@
             <a:avLst/>
           </a:prstGeom>
           <a:solidFill>
-            <a:schemeClr val="accent2"/>
+            <a:schemeClr val="tx2"/>
           </a:solidFill>
           <a:ln/>
         </p:spPr>
@@ -14261,7 +14297,7 @@
             <a:avLst/>
           </a:prstGeom>
           <a:solidFill>
-            <a:schemeClr val="accent2"/>
+            <a:schemeClr val="tx2"/>
           </a:solidFill>
           <a:ln/>
         </p:spPr>
@@ -14368,7 +14404,7 @@
             <a:lvl1pPr>
               <a:defRPr sz="1000">
                 <a:solidFill>
-                  <a:schemeClr val="accent2"/>
+                  <a:schemeClr val="tx2"/>
                 </a:solidFill>
               </a:defRPr>
             </a:lvl1pPr>
@@ -14439,6 +14475,9 @@
                 <a:solidFill>
                   <a:schemeClr val="bg1"/>
                 </a:solidFill>
+                <a:latin typeface="Cambria" pitchFamily="34" charset="0"/>
+                <a:ea typeface="Cambria" pitchFamily="34" charset="-122"/>
+                <a:cs typeface="Cambria" pitchFamily="34" charset="-120"/>
               </a:rPr>
               <a:t>REQUIREMENTS ANALYSIS</a:t>
             </a:r>
@@ -14461,7 +14500,7 @@
             <a:avLst/>
           </a:prstGeom>
           <a:solidFill>
-            <a:schemeClr val="accent2"/>
+            <a:schemeClr val="tx2"/>
           </a:solidFill>
           <a:ln/>
         </p:spPr>
@@ -14523,14 +14562,14 @@
           </a:solidFill>
           <a:ln w="9525">
             <a:solidFill>
-              <a:schemeClr val="accent4"/>
+              <a:srgbClr val="D5DCE8"/>
             </a:solidFill>
             <a:prstDash val="solid"/>
           </a:ln>
           <a:effectLst>
             <a:outerShdw sx="100000" sy="100000" kx="0" ky="0" algn="bl" rotWithShape="0" blurRad="76200" dist="25400" dir="5400000">
-              <a:srgbClr val="8B0000">
-                <a:alpha val="12000"/>
+              <a:srgbClr val="1F3864">
+                <a:alpha val="10000"/>
               </a:srgbClr>
             </a:outerShdw>
           </a:effectLst>
@@ -14563,7 +14602,7 @@
             <a:r>
               <a:rPr lang="en-US" sz="1400" b="1" dirty="0">
                 <a:solidFill>
-                  <a:schemeClr val="accent1"/>
+                  <a:schemeClr val="tx2"/>
                 </a:solidFill>
               </a:rPr>
               <a:t>FR1</a:t>
@@ -14623,7 +14662,7 @@
             <a:avLst/>
           </a:prstGeom>
           <a:solidFill>
-            <a:schemeClr val="accent2"/>
+            <a:schemeClr val="tx2"/>
           </a:solidFill>
           <a:ln/>
         </p:spPr>
@@ -14685,14 +14724,14 @@
           </a:solidFill>
           <a:ln w="9525">
             <a:solidFill>
-              <a:schemeClr val="accent4"/>
+              <a:srgbClr val="D5DCE8"/>
             </a:solidFill>
             <a:prstDash val="solid"/>
           </a:ln>
           <a:effectLst>
             <a:outerShdw sx="100000" sy="100000" kx="0" ky="0" algn="bl" rotWithShape="0" blurRad="76200" dist="25400" dir="5400000">
-              <a:srgbClr val="8B0000">
-                <a:alpha val="12000"/>
+              <a:srgbClr val="1F3864">
+                <a:alpha val="10000"/>
               </a:srgbClr>
             </a:outerShdw>
           </a:effectLst>
@@ -14725,7 +14764,7 @@
             <a:r>
               <a:rPr lang="en-US" sz="1400" b="1" dirty="0">
                 <a:solidFill>
-                  <a:schemeClr val="accent1"/>
+                  <a:schemeClr val="tx2"/>
                 </a:solidFill>
               </a:rPr>
               <a:t>FR2</a:t>
@@ -14785,7 +14824,7 @@
             <a:avLst/>
           </a:prstGeom>
           <a:solidFill>
-            <a:schemeClr val="accent2"/>
+            <a:schemeClr val="tx2"/>
           </a:solidFill>
           <a:ln/>
         </p:spPr>
@@ -14847,14 +14886,14 @@
           </a:solidFill>
           <a:ln w="9525">
             <a:solidFill>
-              <a:schemeClr val="accent4"/>
+              <a:srgbClr val="D5DCE8"/>
             </a:solidFill>
             <a:prstDash val="solid"/>
           </a:ln>
           <a:effectLst>
             <a:outerShdw sx="100000" sy="100000" kx="0" ky="0" algn="bl" rotWithShape="0" blurRad="76200" dist="25400" dir="5400000">
-              <a:srgbClr val="8B0000">
-                <a:alpha val="12000"/>
+              <a:srgbClr val="1F3864">
+                <a:alpha val="10000"/>
               </a:srgbClr>
             </a:outerShdw>
           </a:effectLst>
@@ -14887,7 +14926,7 @@
             <a:r>
               <a:rPr lang="en-US" sz="1400" b="1" dirty="0">
                 <a:solidFill>
-                  <a:schemeClr val="accent1"/>
+                  <a:schemeClr val="tx2"/>
                 </a:solidFill>
               </a:rPr>
               <a:t>FR3</a:t>
@@ -14947,7 +14986,7 @@
             <a:avLst/>
           </a:prstGeom>
           <a:solidFill>
-            <a:schemeClr val="accent2"/>
+            <a:schemeClr val="tx2"/>
           </a:solidFill>
           <a:ln/>
         </p:spPr>
@@ -15009,14 +15048,14 @@
           </a:solidFill>
           <a:ln w="9525">
             <a:solidFill>
-              <a:schemeClr val="accent4"/>
+              <a:srgbClr val="D5DCE8"/>
             </a:solidFill>
             <a:prstDash val="solid"/>
           </a:ln>
           <a:effectLst>
             <a:outerShdw sx="100000" sy="100000" kx="0" ky="0" algn="bl" rotWithShape="0" blurRad="76200" dist="25400" dir="5400000">
-              <a:srgbClr val="8B0000">
-                <a:alpha val="12000"/>
+              <a:srgbClr val="1F3864">
+                <a:alpha val="10000"/>
               </a:srgbClr>
             </a:outerShdw>
           </a:effectLst>
@@ -15049,7 +15088,7 @@
             <a:r>
               <a:rPr lang="en-US" sz="1400" b="1" dirty="0">
                 <a:solidFill>
-                  <a:schemeClr val="accent1"/>
+                  <a:schemeClr val="tx2"/>
                 </a:solidFill>
               </a:rPr>
               <a:t>FR4</a:t>
@@ -15109,7 +15148,7 @@
             <a:avLst/>
           </a:prstGeom>
           <a:solidFill>
-            <a:schemeClr val="accent2"/>
+            <a:schemeClr val="tx2"/>
           </a:solidFill>
           <a:ln/>
         </p:spPr>
@@ -15171,14 +15210,14 @@
           </a:solidFill>
           <a:ln w="9525">
             <a:solidFill>
-              <a:schemeClr val="accent4"/>
+              <a:srgbClr val="D5DCE8"/>
             </a:solidFill>
             <a:prstDash val="solid"/>
           </a:ln>
           <a:effectLst>
             <a:outerShdw sx="100000" sy="100000" kx="0" ky="0" algn="bl" rotWithShape="0" blurRad="76200" dist="25400" dir="5400000">
-              <a:srgbClr val="8B0000">
-                <a:alpha val="12000"/>
+              <a:srgbClr val="1F3864">
+                <a:alpha val="10000"/>
               </a:srgbClr>
             </a:outerShdw>
           </a:effectLst>
@@ -15211,7 +15250,7 @@
             <a:r>
               <a:rPr lang="en-US" sz="1400" b="1" dirty="0">
                 <a:solidFill>
-                  <a:schemeClr val="accent1"/>
+                  <a:schemeClr val="tx2"/>
                 </a:solidFill>
               </a:rPr>
               <a:t>FR5</a:t>
@@ -15271,7 +15310,7 @@
             <a:avLst/>
           </a:prstGeom>
           <a:solidFill>
-            <a:schemeClr val="accent2"/>
+            <a:schemeClr val="tx2"/>
           </a:solidFill>
           <a:ln/>
         </p:spPr>
@@ -15333,14 +15372,14 @@
           </a:solidFill>
           <a:ln w="9525">
             <a:solidFill>
-              <a:schemeClr val="accent4"/>
+              <a:srgbClr val="D5DCE8"/>
             </a:solidFill>
             <a:prstDash val="solid"/>
           </a:ln>
           <a:effectLst>
             <a:outerShdw sx="100000" sy="100000" kx="0" ky="0" algn="bl" rotWithShape="0" blurRad="76200" dist="25400" dir="5400000">
-              <a:srgbClr val="8B0000">
-                <a:alpha val="12000"/>
+              <a:srgbClr val="1F3864">
+                <a:alpha val="10000"/>
               </a:srgbClr>
             </a:outerShdw>
           </a:effectLst>
@@ -15373,7 +15412,7 @@
             <a:r>
               <a:rPr lang="en-US" sz="1400" b="1" dirty="0">
                 <a:solidFill>
-                  <a:schemeClr val="accent1"/>
+                  <a:schemeClr val="tx2"/>
                 </a:solidFill>
               </a:rPr>
               <a:t>FR6</a:t>
@@ -15433,7 +15472,7 @@
             <a:avLst/>
           </a:prstGeom>
           <a:solidFill>
-            <a:schemeClr val="accent2"/>
+            <a:schemeClr val="tx2"/>
           </a:solidFill>
           <a:ln/>
         </p:spPr>
@@ -15495,14 +15534,14 @@
           </a:solidFill>
           <a:ln w="9525">
             <a:solidFill>
-              <a:schemeClr val="accent4"/>
+              <a:srgbClr val="D5DCE8"/>
             </a:solidFill>
             <a:prstDash val="solid"/>
           </a:ln>
           <a:effectLst>
             <a:outerShdw sx="100000" sy="100000" kx="0" ky="0" algn="bl" rotWithShape="0" blurRad="76200" dist="25400" dir="5400000">
-              <a:srgbClr val="8B0000">
-                <a:alpha val="12000"/>
+              <a:srgbClr val="1F3864">
+                <a:alpha val="10000"/>
               </a:srgbClr>
             </a:outerShdw>
           </a:effectLst>
@@ -15535,7 +15574,7 @@
             <a:r>
               <a:rPr lang="en-US" sz="1400" b="1" dirty="0">
                 <a:solidFill>
-                  <a:schemeClr val="accent1"/>
+                  <a:schemeClr val="tx2"/>
                 </a:solidFill>
               </a:rPr>
               <a:t>FR7</a:t>
@@ -15595,7 +15634,7 @@
             <a:avLst/>
           </a:prstGeom>
           <a:solidFill>
-            <a:schemeClr val="accent2"/>
+            <a:schemeClr val="tx2"/>
           </a:solidFill>
           <a:ln/>
         </p:spPr>
@@ -15657,14 +15696,14 @@
           </a:solidFill>
           <a:ln w="9525">
             <a:solidFill>
-              <a:schemeClr val="accent4"/>
+              <a:srgbClr val="D5DCE8"/>
             </a:solidFill>
             <a:prstDash val="solid"/>
           </a:ln>
           <a:effectLst>
             <a:outerShdw sx="100000" sy="100000" kx="0" ky="0" algn="bl" rotWithShape="0" blurRad="76200" dist="25400" dir="5400000">
-              <a:srgbClr val="8B0000">
-                <a:alpha val="12000"/>
+              <a:srgbClr val="1F3864">
+                <a:alpha val="10000"/>
               </a:srgbClr>
             </a:outerShdw>
           </a:effectLst>
@@ -15697,7 +15736,7 @@
             <a:r>
               <a:rPr lang="en-US" sz="1400" b="1" dirty="0">
                 <a:solidFill>
-                  <a:schemeClr val="accent1"/>
+                  <a:schemeClr val="tx2"/>
                 </a:solidFill>
               </a:rPr>
               <a:t>FR8</a:t>
@@ -15757,7 +15796,7 @@
             <a:avLst/>
           </a:prstGeom>
           <a:solidFill>
-            <a:schemeClr val="accent2"/>
+            <a:schemeClr val="tx2"/>
           </a:solidFill>
           <a:ln/>
         </p:spPr>
@@ -15819,14 +15858,14 @@
           </a:solidFill>
           <a:ln w="9525">
             <a:solidFill>
-              <a:schemeClr val="accent4"/>
+              <a:srgbClr val="D5DCE8"/>
             </a:solidFill>
             <a:prstDash val="solid"/>
           </a:ln>
           <a:effectLst>
             <a:outerShdw sx="100000" sy="100000" kx="0" ky="0" algn="bl" rotWithShape="0" blurRad="76200" dist="25400" dir="5400000">
-              <a:srgbClr val="8B0000">
-                <a:alpha val="12000"/>
+              <a:srgbClr val="1F3864">
+                <a:alpha val="10000"/>
               </a:srgbClr>
             </a:outerShdw>
           </a:effectLst>
@@ -15859,7 +15898,7 @@
             <a:r>
               <a:rPr lang="en-US" sz="1400" b="1" dirty="0">
                 <a:solidFill>
-                  <a:schemeClr val="accent1"/>
+                  <a:schemeClr val="tx2"/>
                 </a:solidFill>
               </a:rPr>
               <a:t>FR9</a:t>
@@ -15919,7 +15958,7 @@
             <a:avLst/>
           </a:prstGeom>
           <a:solidFill>
-            <a:schemeClr val="accent4"/>
+            <a:schemeClr val="accent1"/>
           </a:solidFill>
           <a:ln/>
         </p:spPr>
@@ -15951,7 +15990,7 @@
             <a:r>
               <a:rPr lang="en-US" sz="1200" b="1" dirty="0">
                 <a:solidFill>
-                  <a:schemeClr val="accent2"/>
+                  <a:schemeClr val="bg1"/>
                 </a:solidFill>
               </a:rPr>
               <a:t>S</a:t>
@@ -15981,14 +16020,14 @@
           </a:solidFill>
           <a:ln w="9525">
             <a:solidFill>
-              <a:schemeClr val="accent4"/>
+              <a:srgbClr val="D5DCE8"/>
             </a:solidFill>
             <a:prstDash val="solid"/>
           </a:ln>
           <a:effectLst>
             <a:outerShdw sx="100000" sy="100000" kx="0" ky="0" algn="bl" rotWithShape="0" blurRad="76200" dist="25400" dir="5400000">
-              <a:srgbClr val="8B0000">
-                <a:alpha val="12000"/>
+              <a:srgbClr val="1F3864">
+                <a:alpha val="10000"/>
               </a:srgbClr>
             </a:outerShdw>
           </a:effectLst>
@@ -16021,7 +16060,7 @@
             <a:r>
               <a:rPr lang="en-US" sz="1400" b="1" dirty="0">
                 <a:solidFill>
-                  <a:schemeClr val="accent1"/>
+                  <a:schemeClr val="tx2"/>
                 </a:solidFill>
               </a:rPr>
               <a:t>FR10</a:t>
@@ -16078,98 +16117,6 @@
             <a:ext cx="365760" cy="365760"/>
           </a:xfrm>
           <a:prstGeom prst="ellipse">
-            <a:avLst/>
-          </a:prstGeom>
-          <a:solidFill>
-            <a:schemeClr val="accent4"/>
-          </a:solidFill>
-          <a:ln/>
-        </p:spPr>
-      </p:sp>
-      <p:sp>
-        <p:nvSpPr>
-          <p:cNvPr id="54" name="Text 52"/>
-          <p:cNvSpPr txBox="1"/>
-          <p:nvPr/>
-        </p:nvSpPr>
-        <p:spPr>
-          <a:xfrm>
-            <a:off x="6355080" y="5239512"/>
-            <a:ext cx="365760" cy="365760"/>
-          </a:xfrm>
-          <a:prstGeom prst="rect">
-            <a:avLst/>
-          </a:prstGeom>
-          <a:noFill/>
-          <a:ln/>
-        </p:spPr>
-        <p:txBody>
-          <a:bodyPr wrap="square" lIns="0" tIns="0" rIns="0" bIns="0" rtlCol="0" anchor="ctr"/>
-          <a:lstStyle/>
-          <a:p>
-            <a:pPr algn="ctr" indent="0" marL="0">
-              <a:buNone/>
-            </a:pPr>
-            <a:r>
-              <a:rPr lang="en-US" sz="1200" b="1" dirty="0">
-                <a:solidFill>
-                  <a:schemeClr val="accent2"/>
-                </a:solidFill>
-              </a:rPr>
-              <a:t>S</a:t>
-            </a:r>
-            <a:endParaRPr lang="en-US" sz="1200" dirty="0"/>
-          </a:p>
-        </p:txBody>
-      </p:sp>
-      <p:sp>
-        <p:nvSpPr>
-          <p:cNvPr id="55" name="Text 53"/>
-          <p:cNvSpPr txBox="1"/>
-          <p:nvPr/>
-        </p:nvSpPr>
-        <p:spPr>
-          <a:xfrm>
-            <a:off x="548640" y="6035040"/>
-            <a:ext cx="3657600" cy="274320"/>
-          </a:xfrm>
-          <a:prstGeom prst="rect">
-            <a:avLst/>
-          </a:prstGeom>
-          <a:noFill/>
-          <a:ln/>
-        </p:spPr>
-        <p:txBody>
-          <a:bodyPr wrap="square" lIns="0" tIns="0" rIns="0" bIns="0" rtlCol="0" anchor="t"/>
-          <a:lstStyle/>
-          <a:p>
-            <a:pPr indent="0" marL="0">
-              <a:buNone/>
-            </a:pPr>
-            <a:r>
-              <a:rPr lang="en-US" sz="1100" dirty="0">
-                <a:solidFill>
-                  <a:schemeClr val="tx2"/>
-                </a:solidFill>
-              </a:rPr>
-              <a:t>M = Must · S = Should</a:t>
-            </a:r>
-            <a:endParaRPr lang="en-US" sz="1100" dirty="0"/>
-          </a:p>
-        </p:txBody>
-      </p:sp>
-      <p:sp>
-        <p:nvSpPr>
-          <p:cNvPr id="56" name="Header Measurable non-functional targets"/>
-          <p:cNvSpPr/>
-          <p:nvPr/>
-        </p:nvSpPr>
-        <p:spPr>
-          <a:xfrm>
-            <a:off x="7159752" y="1234440"/>
-            <a:ext cx="4480560" cy="384048"/>
-          </a:xfrm>
-          <a:prstGeom prst="rect">
             <a:avLst/>
           </a:prstGeom>
           <a:solidFill>
@@ -16180,6 +16127,98 @@
       </p:sp>
       <p:sp>
         <p:nvSpPr>
+          <p:cNvPr id="54" name="Text 52"/>
+          <p:cNvSpPr txBox="1"/>
+          <p:nvPr/>
+        </p:nvSpPr>
+        <p:spPr>
+          <a:xfrm>
+            <a:off x="6355080" y="5239512"/>
+            <a:ext cx="365760" cy="365760"/>
+          </a:xfrm>
+          <a:prstGeom prst="rect">
+            <a:avLst/>
+          </a:prstGeom>
+          <a:noFill/>
+          <a:ln/>
+        </p:spPr>
+        <p:txBody>
+          <a:bodyPr wrap="square" lIns="0" tIns="0" rIns="0" bIns="0" rtlCol="0" anchor="ctr"/>
+          <a:lstStyle/>
+          <a:p>
+            <a:pPr algn="ctr" indent="0" marL="0">
+              <a:buNone/>
+            </a:pPr>
+            <a:r>
+              <a:rPr lang="en-US" sz="1200" b="1" dirty="0">
+                <a:solidFill>
+                  <a:schemeClr val="bg1"/>
+                </a:solidFill>
+              </a:rPr>
+              <a:t>S</a:t>
+            </a:r>
+            <a:endParaRPr lang="en-US" sz="1200" dirty="0"/>
+          </a:p>
+        </p:txBody>
+      </p:sp>
+      <p:sp>
+        <p:nvSpPr>
+          <p:cNvPr id="55" name="Text 53"/>
+          <p:cNvSpPr txBox="1"/>
+          <p:nvPr/>
+        </p:nvSpPr>
+        <p:spPr>
+          <a:xfrm>
+            <a:off x="548640" y="6035040"/>
+            <a:ext cx="3657600" cy="274320"/>
+          </a:xfrm>
+          <a:prstGeom prst="rect">
+            <a:avLst/>
+          </a:prstGeom>
+          <a:noFill/>
+          <a:ln/>
+        </p:spPr>
+        <p:txBody>
+          <a:bodyPr wrap="square" lIns="0" tIns="0" rIns="0" bIns="0" rtlCol="0" anchor="t"/>
+          <a:lstStyle/>
+          <a:p>
+            <a:pPr indent="0" marL="0">
+              <a:buNone/>
+            </a:pPr>
+            <a:r>
+              <a:rPr lang="en-US" sz="1100" dirty="0">
+                <a:solidFill>
+                  <a:schemeClr val="tx2"/>
+                </a:solidFill>
+              </a:rPr>
+              <a:t>M = Must · S = Should</a:t>
+            </a:r>
+            <a:endParaRPr lang="en-US" sz="1100" dirty="0"/>
+          </a:p>
+        </p:txBody>
+      </p:sp>
+      <p:sp>
+        <p:nvSpPr>
+          <p:cNvPr id="56" name="Header Measurable non-functional targets"/>
+          <p:cNvSpPr/>
+          <p:nvPr/>
+        </p:nvSpPr>
+        <p:spPr>
+          <a:xfrm>
+            <a:off x="7159752" y="1234440"/>
+            <a:ext cx="4480560" cy="384048"/>
+          </a:xfrm>
+          <a:prstGeom prst="rect">
+            <a:avLst/>
+          </a:prstGeom>
+          <a:solidFill>
+            <a:schemeClr val="accent2"/>
+          </a:solidFill>
+          <a:ln/>
+        </p:spPr>
+      </p:sp>
+      <p:sp>
+        <p:nvSpPr>
           <p:cNvPr id="57" name="Text 55"/>
           <p:cNvSpPr txBox="1"/>
           <p:nvPr/>
@@ -16229,7 +16268,7 @@
             <a:avLst/>
           </a:prstGeom>
           <a:solidFill>
-            <a:schemeClr val="accent5"/>
+            <a:schemeClr val="bg2"/>
           </a:solidFill>
           <a:ln/>
         </p:spPr>
@@ -16261,7 +16300,7 @@
             <a:r>
               <a:rPr lang="en-US" sz="1700" b="1" dirty="0">
                 <a:solidFill>
-                  <a:schemeClr val="accent1"/>
+                  <a:schemeClr val="accent2"/>
                 </a:solidFill>
               </a:rPr>
               <a:t>12</a:t>
@@ -16321,7 +16360,7 @@
             <a:avLst/>
           </a:prstGeom>
           <a:solidFill>
-            <a:schemeClr val="accent5"/>
+            <a:schemeClr val="bg2"/>
           </a:solidFill>
           <a:ln/>
         </p:spPr>
@@ -16353,7 +16392,7 @@
             <a:r>
               <a:rPr lang="en-US" sz="1700" b="1" dirty="0">
                 <a:solidFill>
-                  <a:schemeClr val="accent1"/>
+                  <a:schemeClr val="accent2"/>
                 </a:solidFill>
               </a:rPr>
               <a:t>15 min</a:t>
@@ -16413,7 +16452,7 @@
             <a:avLst/>
           </a:prstGeom>
           <a:solidFill>
-            <a:schemeClr val="accent5"/>
+            <a:schemeClr val="bg2"/>
           </a:solidFill>
           <a:ln/>
         </p:spPr>
@@ -16445,7 +16484,7 @@
             <a:r>
               <a:rPr lang="en-US" sz="1700" b="1" dirty="0">
                 <a:solidFill>
-                  <a:schemeClr val="accent1"/>
+                  <a:schemeClr val="accent2"/>
                 </a:solidFill>
               </a:rPr>
               <a:t>30 s</a:t>
@@ -16505,7 +16544,7 @@
             <a:avLst/>
           </a:prstGeom>
           <a:solidFill>
-            <a:schemeClr val="accent5"/>
+            <a:schemeClr val="bg2"/>
           </a:solidFill>
           <a:ln/>
         </p:spPr>
@@ -16537,7 +16576,7 @@
             <a:r>
               <a:rPr lang="en-US" sz="1700" b="1" dirty="0">
                 <a:solidFill>
-                  <a:schemeClr val="accent1"/>
+                  <a:schemeClr val="accent2"/>
                 </a:solidFill>
               </a:rPr>
               <a:t>15</a:t>
@@ -16597,7 +16636,7 @@
             <a:avLst/>
           </a:prstGeom>
           <a:solidFill>
-            <a:schemeClr val="accent5"/>
+            <a:schemeClr val="bg2"/>
           </a:solidFill>
           <a:ln/>
         </p:spPr>
@@ -16629,7 +16668,7 @@
             <a:r>
               <a:rPr lang="en-US" sz="1700" b="1" dirty="0">
                 <a:solidFill>
-                  <a:schemeClr val="accent1"/>
+                  <a:schemeClr val="accent2"/>
                 </a:solidFill>
               </a:rPr>
               <a:t>EN · FR</a:t>
@@ -16704,7 +16743,7 @@
             <a:lvl1pPr>
               <a:defRPr sz="1000">
                 <a:solidFill>
-                  <a:schemeClr val="accent2"/>
+                  <a:schemeClr val="tx2"/>
                 </a:solidFill>
               </a:defRPr>
             </a:lvl1pPr>
@@ -16775,6 +16814,9 @@
                 <a:solidFill>
                   <a:schemeClr val="bg1"/>
                 </a:solidFill>
+                <a:latin typeface="Cambria" pitchFamily="34" charset="0"/>
+                <a:ea typeface="Cambria" pitchFamily="34" charset="-122"/>
+                <a:cs typeface="Cambria" pitchFamily="34" charset="-120"/>
               </a:rPr>
               <a:t>SYSTEM ARCHITECTURE &amp; TECHNOLOGIES: MERN STACK IN MVC</a:t>
             </a:r>
@@ -16803,14 +16845,14 @@
           </a:solidFill>
           <a:ln w="9525">
             <a:solidFill>
-              <a:schemeClr val="accent4"/>
+              <a:srgbClr val="D5DCE8"/>
             </a:solidFill>
             <a:prstDash val="solid"/>
           </a:ln>
           <a:effectLst>
             <a:outerShdw sx="100000" sy="100000" kx="0" ky="0" algn="bl" rotWithShape="0" blurRad="76200" dist="25400" dir="5400000">
-              <a:srgbClr val="8B0000">
-                <a:alpha val="12000"/>
+              <a:srgbClr val="1F3864">
+                <a:alpha val="10000"/>
               </a:srgbClr>
             </a:outerShdw>
           </a:effectLst>
@@ -16859,7 +16901,7 @@
           </a:solidFill>
           <a:ln w="9525">
             <a:solidFill>
-              <a:schemeClr val="accent4"/>
+              <a:srgbClr val="D5DCE8"/>
             </a:solidFill>
             <a:prstDash val="solid"/>
           </a:ln>
@@ -16892,7 +16934,7 @@
             <a:r>
               <a:rPr lang="en-US" sz="1300" b="1" dirty="0">
                 <a:solidFill>
-                  <a:schemeClr val="accent2"/>
+                  <a:schemeClr val="tx2"/>
                 </a:solidFill>
               </a:rPr>
               <a:t>View (front-end)</a:t>
@@ -16930,11 +16972,11 @@
             <a:avLst/>
           </a:prstGeom>
           <a:solidFill>
-            <a:schemeClr val="accent5"/>
+            <a:schemeClr val="bg2"/>
           </a:solidFill>
           <a:ln w="9525">
             <a:solidFill>
-              <a:schemeClr val="accent4"/>
+              <a:srgbClr val="D5DCE8"/>
             </a:solidFill>
             <a:prstDash val="solid"/>
           </a:ln>
@@ -16967,7 +17009,7 @@
             <a:r>
               <a:rPr lang="en-US" sz="1300" b="1" dirty="0">
                 <a:solidFill>
-                  <a:schemeClr val="accent2"/>
+                  <a:schemeClr val="tx2"/>
                 </a:solidFill>
               </a:rPr>
               <a:t>Controller (back-end)</a:t>
@@ -17009,7 +17051,7 @@
           </a:solidFill>
           <a:ln w="9525">
             <a:solidFill>
-              <a:schemeClr val="accent4"/>
+              <a:srgbClr val="D5DCE8"/>
             </a:solidFill>
             <a:prstDash val="solid"/>
           </a:ln>
@@ -17042,7 +17084,7 @@
             <a:r>
               <a:rPr lang="en-US" sz="1300" b="1" dirty="0">
                 <a:solidFill>
-                  <a:schemeClr val="accent2"/>
+                  <a:schemeClr val="tx2"/>
                 </a:solidFill>
               </a:rPr>
               <a:t>Model (database)</a:t>
@@ -17080,11 +17122,11 @@
             <a:avLst/>
           </a:prstGeom>
           <a:solidFill>
-            <a:schemeClr val="accent5"/>
+            <a:schemeClr val="bg2"/>
           </a:solidFill>
           <a:ln w="9525">
             <a:solidFill>
-              <a:schemeClr val="accent4"/>
+              <a:srgbClr val="D5DCE8"/>
             </a:solidFill>
             <a:prstDash val="solid"/>
           </a:ln>
@@ -17117,7 +17159,7 @@
             <a:r>
               <a:rPr lang="en-US" sz="1300" b="1" dirty="0">
                 <a:solidFill>
-                  <a:schemeClr val="accent2"/>
+                  <a:schemeClr val="tx2"/>
                 </a:solidFill>
               </a:rPr>
               <a:t>AI service</a:t>
@@ -17159,7 +17201,7 @@
           </a:solidFill>
           <a:ln w="9525">
             <a:solidFill>
-              <a:schemeClr val="accent4"/>
+              <a:srgbClr val="D5DCE8"/>
             </a:solidFill>
             <a:prstDash val="solid"/>
           </a:ln>
@@ -17192,7 +17234,7 @@
             <a:r>
               <a:rPr lang="en-US" sz="1300" b="1" dirty="0">
                 <a:solidFill>
-                  <a:schemeClr val="accent2"/>
+                  <a:schemeClr val="tx2"/>
                 </a:solidFill>
               </a:rPr>
               <a:t>Security</a:t>
@@ -17245,7 +17287,7 @@
             <a:lvl1pPr>
               <a:defRPr sz="1000">
                 <a:solidFill>
-                  <a:schemeClr val="accent2"/>
+                  <a:schemeClr val="tx2"/>
                 </a:solidFill>
               </a:defRPr>
             </a:lvl1pPr>
@@ -17269,49 +17311,49 @@
 </file>
 
 <file path=ppt/theme/theme1.xml><?xml version="1.0" encoding="utf-8"?>
-<a:theme xmlns:a="http://schemas.openxmlformats.org/drawingml/2006/main" name="ExamGrade Red">
+<a:theme xmlns:a="http://schemas.openxmlformats.org/drawingml/2006/main" name="ExamGrade">
   <a:themeElements>
-    <a:clrScheme name="ExamGrade Red">
+    <a:clrScheme name="ExamGrade">
       <a:dk1>
-        <a:srgbClr val="2C2C2C"/>
+        <a:srgbClr val="1F2937"/>
       </a:dk1>
       <a:lt1>
         <a:srgbClr val="FFFFFF"/>
       </a:lt1>
       <a:dk2>
-        <a:srgbClr val="8B0000"/>
+        <a:srgbClr val="1F3864"/>
       </a:dk2>
       <a:lt2>
-        <a:srgbClr val="FDF6F0"/>
+        <a:srgbClr val="EEF2F8"/>
       </a:lt2>
       <a:accent1>
-        <a:srgbClr val="B22222"/>
+        <a:srgbClr val="D9A62E"/>
       </a:accent1>
       <a:accent2>
-        <a:srgbClr val="8B0000"/>
+        <a:srgbClr val="0F766E"/>
       </a:accent2>
       <a:accent3>
-        <a:srgbClr val="6B0000"/>
+        <a:srgbClr val="64748B"/>
       </a:accent3>
       <a:accent4>
-        <a:srgbClr val="FFCCCC"/>
+        <a:srgbClr val="E6F4F1"/>
       </a:accent4>
       <a:accent5>
-        <a:srgbClr val="F8E5E5"/>
+        <a:srgbClr val="FDF3DC"/>
       </a:accent5>
       <a:accent6>
-        <a:srgbClr val="1E7B34"/>
+        <a:srgbClr val="B91C1C"/>
       </a:accent6>
       <a:hlink>
-        <a:srgbClr val="B22222"/>
+        <a:srgbClr val="1F3864"/>
       </a:hlink>
       <a:folHlink>
-        <a:srgbClr val="8B0000"/>
+        <a:srgbClr val="64748B"/>
       </a:folHlink>
     </a:clrScheme>
-    <a:fontScheme name="ExamGrade Red">
+    <a:fontScheme name="ExamGrade">
       <a:majorFont>
-        <a:latin typeface="Calibri"/>
+        <a:latin typeface="Cambria"/>
         <a:ea typeface=""/>
         <a:cs typeface=""/>
         <a:font script="Jpan" typeface="游ゴシック Light"/>

</xml_diff>